<commit_message>
updated codes for plotting and manuscripts
</commit_message>
<xml_diff>
--- a/figs/alt_factors.pptx
+++ b/figs/alt_factors.pptx
@@ -197,7 +197,7 @@
           <a:p>
             <a:fld id="{ED6F375F-3D7B-C74C-A441-7DBD899A7ADA}" type="datetimeFigureOut">
               <a:rPr lang="en-US" smtClean="0"/>
-              <a:t>8/13/25</a:t>
+              <a:t>11/3/25</a:t>
             </a:fld>
             <a:endParaRPr lang="en-US"/>
           </a:p>
@@ -679,7 +679,7 @@
           <a:p>
             <a:fld id="{E0A7F3C6-471F-5F4E-8C20-AA410BAABE74}" type="datetimeFigureOut">
               <a:rPr lang="en-US" smtClean="0"/>
-              <a:t>8/13/25</a:t>
+              <a:t>11/3/25</a:t>
             </a:fld>
             <a:endParaRPr lang="en-US"/>
           </a:p>
@@ -849,7 +849,7 @@
           <a:p>
             <a:fld id="{E0A7F3C6-471F-5F4E-8C20-AA410BAABE74}" type="datetimeFigureOut">
               <a:rPr lang="en-US" smtClean="0"/>
-              <a:t>8/13/25</a:t>
+              <a:t>11/3/25</a:t>
             </a:fld>
             <a:endParaRPr lang="en-US"/>
           </a:p>
@@ -1029,7 +1029,7 @@
           <a:p>
             <a:fld id="{E0A7F3C6-471F-5F4E-8C20-AA410BAABE74}" type="datetimeFigureOut">
               <a:rPr lang="en-US" smtClean="0"/>
-              <a:t>8/13/25</a:t>
+              <a:t>11/3/25</a:t>
             </a:fld>
             <a:endParaRPr lang="en-US"/>
           </a:p>
@@ -1199,7 +1199,7 @@
           <a:p>
             <a:fld id="{E0A7F3C6-471F-5F4E-8C20-AA410BAABE74}" type="datetimeFigureOut">
               <a:rPr lang="en-US" smtClean="0"/>
-              <a:t>8/13/25</a:t>
+              <a:t>11/3/25</a:t>
             </a:fld>
             <a:endParaRPr lang="en-US"/>
           </a:p>
@@ -1445,7 +1445,7 @@
           <a:p>
             <a:fld id="{E0A7F3C6-471F-5F4E-8C20-AA410BAABE74}" type="datetimeFigureOut">
               <a:rPr lang="en-US" smtClean="0"/>
-              <a:t>8/13/25</a:t>
+              <a:t>11/3/25</a:t>
             </a:fld>
             <a:endParaRPr lang="en-US"/>
           </a:p>
@@ -1677,7 +1677,7 @@
           <a:p>
             <a:fld id="{E0A7F3C6-471F-5F4E-8C20-AA410BAABE74}" type="datetimeFigureOut">
               <a:rPr lang="en-US" smtClean="0"/>
-              <a:t>8/13/25</a:t>
+              <a:t>11/3/25</a:t>
             </a:fld>
             <a:endParaRPr lang="en-US"/>
           </a:p>
@@ -2044,7 +2044,7 @@
           <a:p>
             <a:fld id="{E0A7F3C6-471F-5F4E-8C20-AA410BAABE74}" type="datetimeFigureOut">
               <a:rPr lang="en-US" smtClean="0"/>
-              <a:t>8/13/25</a:t>
+              <a:t>11/3/25</a:t>
             </a:fld>
             <a:endParaRPr lang="en-US"/>
           </a:p>
@@ -2162,7 +2162,7 @@
           <a:p>
             <a:fld id="{E0A7F3C6-471F-5F4E-8C20-AA410BAABE74}" type="datetimeFigureOut">
               <a:rPr lang="en-US" smtClean="0"/>
-              <a:t>8/13/25</a:t>
+              <a:t>11/3/25</a:t>
             </a:fld>
             <a:endParaRPr lang="en-US"/>
           </a:p>
@@ -2257,7 +2257,7 @@
           <a:p>
             <a:fld id="{E0A7F3C6-471F-5F4E-8C20-AA410BAABE74}" type="datetimeFigureOut">
               <a:rPr lang="en-US" smtClean="0"/>
-              <a:t>8/13/25</a:t>
+              <a:t>11/3/25</a:t>
             </a:fld>
             <a:endParaRPr lang="en-US"/>
           </a:p>
@@ -2534,7 +2534,7 @@
           <a:p>
             <a:fld id="{E0A7F3C6-471F-5F4E-8C20-AA410BAABE74}" type="datetimeFigureOut">
               <a:rPr lang="en-US" smtClean="0"/>
-              <a:t>8/13/25</a:t>
+              <a:t>11/3/25</a:t>
             </a:fld>
             <a:endParaRPr lang="en-US"/>
           </a:p>
@@ -2791,7 +2791,7 @@
           <a:p>
             <a:fld id="{E0A7F3C6-471F-5F4E-8C20-AA410BAABE74}" type="datetimeFigureOut">
               <a:rPr lang="en-US" smtClean="0"/>
-              <a:t>8/13/25</a:t>
+              <a:t>11/3/25</a:t>
             </a:fld>
             <a:endParaRPr lang="en-US"/>
           </a:p>
@@ -3004,7 +3004,7 @@
           <a:p>
             <a:fld id="{E0A7F3C6-471F-5F4E-8C20-AA410BAABE74}" type="datetimeFigureOut">
               <a:rPr lang="en-US" smtClean="0"/>
-              <a:t>8/13/25</a:t>
+              <a:t>11/3/25</a:t>
             </a:fld>
             <a:endParaRPr lang="en-US"/>
           </a:p>
@@ -3411,10 +3411,10 @@
       </p:grpSpPr>
       <p:grpSp>
         <p:nvGrpSpPr>
-          <p:cNvPr id="346" name="Group 345">
+          <p:cNvPr id="11" name="Group 10">
             <a:extLst>
               <a:ext uri="{FF2B5EF4-FFF2-40B4-BE49-F238E27FC236}">
-                <a16:creationId xmlns:a16="http://schemas.microsoft.com/office/drawing/2014/main" id="{ACE61366-C8F0-D48E-606A-83277DF2D446}"/>
+                <a16:creationId xmlns:a16="http://schemas.microsoft.com/office/drawing/2014/main" id="{69F4B835-0709-387F-00E1-FD71AF9360E8}"/>
               </a:ext>
             </a:extLst>
           </p:cNvPr>
@@ -3423,14 +3423,14 @@
         </p:nvGrpSpPr>
         <p:grpSpPr>
           <a:xfrm>
-            <a:off x="1154301" y="259208"/>
-            <a:ext cx="9883397" cy="6292938"/>
-            <a:chOff x="1154301" y="259208"/>
-            <a:chExt cx="9883397" cy="6292938"/>
+            <a:off x="1138912" y="259208"/>
+            <a:ext cx="9898786" cy="6326061"/>
+            <a:chOff x="1138912" y="259208"/>
+            <a:chExt cx="9898786" cy="6326061"/>
           </a:xfrm>
         </p:grpSpPr>
-        <mc:AlternateContent xmlns:mc="http://schemas.openxmlformats.org/markup-compatibility/2006" xmlns:a14="http://schemas.microsoft.com/office/drawing/2010/main">
-          <mc:Choice Requires="a14">
+        <mc:AlternateContent xmlns:mc="http://schemas.openxmlformats.org/markup-compatibility/2006">
+          <mc:Choice xmlns:a14="http://schemas.microsoft.com/office/drawing/2010/main" Requires="a14">
             <p:sp>
               <p:nvSpPr>
                 <p:cNvPr id="1244" name="TextBox 1243">
@@ -3445,8 +3445,8 @@
               </p:nvSpPr>
               <p:spPr>
                 <a:xfrm rot="16200000">
-                  <a:off x="1364095" y="1739090"/>
-                  <a:ext cx="2311790" cy="253916"/>
+                  <a:off x="1232302" y="1715207"/>
+                  <a:ext cx="2575377" cy="284693"/>
                 </a:xfrm>
                 <a:prstGeom prst="rect">
                   <a:avLst/>
@@ -3464,7 +3464,7 @@
                 <a:p>
                   <a:pPr algn="l"/>
                   <a:r>
-                    <a:rPr lang="en-US" sz="1200" b="1" dirty="0">
+                    <a:rPr lang="en-US" sz="1400" b="1" dirty="0">
                       <a:ln/>
                       <a:solidFill>
                         <a:srgbClr val="333333"/>
@@ -3474,12 +3474,25 @@
                       <a:sym typeface="Arial"/>
                       <a:rtl val="0"/>
                     </a:rPr>
-                    <a:t>Emissions rate (</a:t>
+                    <a:t>Emissions </a:t>
+                  </a:r>
+                  <a:r>
+                    <a:rPr lang="en-US" sz="1400" b="1" dirty="0">
+                      <a:ln/>
+                      <a:solidFill>
+                        <a:srgbClr val="333333"/>
+                      </a:solidFill>
+                      <a:latin typeface="Arial" panose="020B0604020202020204" pitchFamily="34" charset="0"/>
+                      <a:cs typeface="Arial" panose="020B0604020202020204" pitchFamily="34" charset="0"/>
+                      <a:sym typeface="Arial"/>
+                      <a:rtl val="0"/>
+                    </a:rPr>
+                    <a:t>rate (</a:t>
                   </a:r>
                   <a14:m>
                     <m:oMath xmlns:m="http://schemas.openxmlformats.org/officeDocument/2006/math">
                       <m:r>
-                        <a:rPr lang="en-US" sz="1200" b="1" i="1" smtClean="0">
+                        <a:rPr lang="en-US" sz="1400" b="1" i="0" smtClean="0">
                           <a:ln/>
                           <a:solidFill>
                             <a:srgbClr val="333333"/>
@@ -3489,12 +3502,12 @@
                           <a:sym typeface="Arial"/>
                           <a:rtl val="0"/>
                         </a:rPr>
-                        <m:t>𝒈</m:t>
+                        <m:t>𝐠</m:t>
                       </m:r>
                       <m:sSub>
                         <m:sSubPr>
                           <m:ctrlPr>
-                            <a:rPr lang="en-US" sz="1200" b="1" i="1" smtClean="0">
+                            <a:rPr lang="en-US" sz="1400" b="1" i="1" smtClean="0">
                               <a:ln/>
                               <a:solidFill>
                                 <a:srgbClr val="333333"/>
@@ -3508,7 +3521,7 @@
                         </m:sSubPr>
                         <m:e>
                           <m:r>
-                            <a:rPr lang="en-US" sz="1200" b="1" i="1" smtClean="0">
+                            <a:rPr lang="en-US" sz="1400" b="1" i="0" smtClean="0">
                               <a:ln/>
                               <a:solidFill>
                                 <a:srgbClr val="333333"/>
@@ -3518,12 +3531,12 @@
                               <a:sym typeface="Arial"/>
                               <a:rtl val="0"/>
                             </a:rPr>
-                            <m:t>𝑪𝑶</m:t>
+                            <m:t>𝐂𝐎</m:t>
                           </m:r>
                         </m:e>
                         <m:sub>
                           <m:r>
-                            <a:rPr lang="en-US" sz="1200" b="1" i="1" smtClean="0">
+                            <a:rPr lang="en-US" sz="1400" b="1" i="0" smtClean="0">
                               <a:ln/>
                               <a:solidFill>
                                 <a:srgbClr val="333333"/>
@@ -3538,7 +3551,7 @@
                         </m:sub>
                       </m:sSub>
                       <m:r>
-                        <a:rPr lang="en-US" sz="1200" b="1" i="1" smtClean="0">
+                        <a:rPr lang="en-US" sz="1400" b="1" i="0" smtClean="0">
                           <a:ln/>
                           <a:solidFill>
                             <a:srgbClr val="333333"/>
@@ -3548,10 +3561,10 @@
                           <a:sym typeface="Arial"/>
                           <a:rtl val="0"/>
                         </a:rPr>
-                        <m:t>𝒆</m:t>
+                        <m:t>𝐞</m:t>
                       </m:r>
                       <m:r>
-                        <a:rPr lang="en-US" sz="1200" b="1" i="1" smtClean="0">
+                        <a:rPr lang="en-US" sz="1400" b="1" i="0" smtClean="0">
                           <a:ln/>
                           <a:solidFill>
                             <a:srgbClr val="333333"/>
@@ -3564,7 +3577,7 @@
                         <m:t>/</m:t>
                       </m:r>
                       <m:r>
-                        <a:rPr lang="en-US" sz="1200" b="1" i="1" smtClean="0">
+                        <a:rPr lang="en-US" sz="1400" b="1" i="0" smtClean="0">
                           <a:ln/>
                           <a:solidFill>
                             <a:srgbClr val="333333"/>
@@ -3574,18 +3587,18 @@
                           <a:sym typeface="Arial"/>
                           <a:rtl val="0"/>
                         </a:rPr>
-                        <m:t>𝒌𝑾𝒉</m:t>
+                        <m:t>𝐤𝐖𝐡</m:t>
                       </m:r>
                     </m:oMath>
                   </a14:m>
                   <a:r>
-                    <a:rPr lang="en-US" sz="1200" b="1" dirty="0">
+                    <a:rPr lang="en-US" sz="1400" b="1" dirty="0">
                       <a:ln/>
                       <a:solidFill>
                         <a:srgbClr val="333333"/>
                       </a:solidFill>
-                      <a:latin typeface="Arial"/>
-                      <a:cs typeface="Arial"/>
+                      <a:latin typeface="Arial" panose="020B0604020202020204" pitchFamily="34" charset="0"/>
+                      <a:cs typeface="Arial" panose="020B0604020202020204" pitchFamily="34" charset="0"/>
                       <a:sym typeface="Arial"/>
                       <a:rtl val="0"/>
                     </a:rPr>
@@ -3595,7 +3608,7 @@
               </p:txBody>
             </p:sp>
           </mc:Choice>
-          <mc:Fallback xmlns="">
+          <mc:Fallback>
             <p:sp>
               <p:nvSpPr>
                 <p:cNvPr id="1244" name="TextBox 1243">
@@ -3612,8 +3625,8 @@
               </p:nvSpPr>
               <p:spPr>
                 <a:xfrm rot="16200000">
-                  <a:off x="1364095" y="1739090"/>
-                  <a:ext cx="2311790" cy="253916"/>
+                  <a:off x="1232302" y="1715207"/>
+                  <a:ext cx="2575377" cy="284693"/>
                 </a:xfrm>
                 <a:prstGeom prst="rect">
                   <a:avLst/>
@@ -3621,7 +3634,7 @@
                 <a:blipFill>
                   <a:blip r:embed="rId3"/>
                   <a:stretch>
-                    <a:fillRect l="-4762" r="-23810" b="-1087"/>
+                    <a:fillRect l="-8696" t="-490" r="-26087" b="-1961"/>
                   </a:stretch>
                 </a:blipFill>
               </p:spPr>
@@ -3656,8 +3669,8 @@
               </p:nvSpPr>
               <p:spPr>
                 <a:xfrm rot="16200000">
-                  <a:off x="118323" y="4810004"/>
-                  <a:ext cx="2325871" cy="253916"/>
+                  <a:off x="-54190" y="4786862"/>
+                  <a:ext cx="2670897" cy="284693"/>
                 </a:xfrm>
                 <a:prstGeom prst="rect">
                   <a:avLst/>
@@ -3675,7 +3688,7 @@
                 <a:p>
                   <a:pPr algn="l"/>
                   <a:r>
-                    <a:rPr lang="en-US" sz="1200" b="1" dirty="0">
+                    <a:rPr lang="en-US" sz="1400" b="1" dirty="0">
                       <a:ln/>
                       <a:solidFill>
                         <a:srgbClr val="333333"/>
@@ -3685,12 +3698,12 @@
                       <a:sym typeface="Arial"/>
                       <a:rtl val="0"/>
                     </a:rPr>
-                    <a:t>Emissions rate (</a:t>
+                    <a:t>Emission rates (</a:t>
                   </a:r>
                   <a14:m>
                     <m:oMath xmlns:m="http://schemas.openxmlformats.org/officeDocument/2006/math">
                       <m:r>
-                        <a:rPr lang="en-US" sz="1200" b="1" i="1" smtClean="0">
+                        <a:rPr lang="en-US" sz="1400" b="1" i="0" smtClean="0">
                           <a:ln/>
                           <a:solidFill>
                             <a:srgbClr val="333333"/>
@@ -3700,12 +3713,12 @@
                           <a:sym typeface="Arial"/>
                           <a:rtl val="0"/>
                         </a:rPr>
-                        <m:t>𝒈</m:t>
+                        <m:t>𝐠</m:t>
                       </m:r>
                       <m:sSub>
                         <m:sSubPr>
                           <m:ctrlPr>
-                            <a:rPr lang="en-US" sz="1200" b="1" i="1" smtClean="0">
+                            <a:rPr lang="en-US" sz="1400" b="1" i="1" smtClean="0">
                               <a:ln/>
                               <a:solidFill>
                                 <a:srgbClr val="333333"/>
@@ -3719,7 +3732,7 @@
                         </m:sSubPr>
                         <m:e>
                           <m:r>
-                            <a:rPr lang="en-US" sz="1200" b="1" i="1" smtClean="0">
+                            <a:rPr lang="en-US" sz="1400" b="1" i="0" smtClean="0">
                               <a:ln/>
                               <a:solidFill>
                                 <a:srgbClr val="333333"/>
@@ -3729,12 +3742,12 @@
                               <a:sym typeface="Arial"/>
                               <a:rtl val="0"/>
                             </a:rPr>
-                            <m:t>𝑪𝑶</m:t>
+                            <m:t>𝐂𝐎</m:t>
                           </m:r>
                         </m:e>
                         <m:sub>
                           <m:r>
-                            <a:rPr lang="en-US" sz="1200" b="1" i="1" smtClean="0">
+                            <a:rPr lang="en-US" sz="1400" b="1" i="0" smtClean="0">
                               <a:ln/>
                               <a:solidFill>
                                 <a:srgbClr val="333333"/>
@@ -3749,7 +3762,7 @@
                         </m:sub>
                       </m:sSub>
                       <m:r>
-                        <a:rPr lang="en-US" sz="1200" b="1" i="1" smtClean="0">
+                        <a:rPr lang="en-US" sz="1400" b="1" i="0" smtClean="0">
                           <a:ln/>
                           <a:solidFill>
                             <a:srgbClr val="333333"/>
@@ -3759,10 +3772,10 @@
                           <a:sym typeface="Arial"/>
                           <a:rtl val="0"/>
                         </a:rPr>
-                        <m:t>𝒆</m:t>
+                        <m:t>𝐞</m:t>
                       </m:r>
                       <m:r>
-                        <a:rPr lang="en-US" sz="1200" b="1" i="1" smtClean="0">
+                        <a:rPr lang="en-US" sz="1400" b="1" i="0" smtClean="0">
                           <a:ln/>
                           <a:solidFill>
                             <a:srgbClr val="333333"/>
@@ -3775,7 +3788,7 @@
                         <m:t>/</m:t>
                       </m:r>
                       <m:r>
-                        <a:rPr lang="en-US" sz="1200" b="1" i="1" smtClean="0">
+                        <a:rPr lang="en-US" sz="1400" b="1" i="0" smtClean="0">
                           <a:ln/>
                           <a:solidFill>
                             <a:srgbClr val="333333"/>
@@ -3785,10 +3798,10 @@
                           <a:sym typeface="Arial"/>
                           <a:rtl val="0"/>
                         </a:rPr>
-                        <m:t>𝒌𝑾𝒉</m:t>
+                        <m:t>𝐤𝐖𝐡</m:t>
                       </m:r>
                       <m:r>
-                        <a:rPr lang="en-US" sz="1200" b="1" i="1" smtClean="0">
+                        <a:rPr lang="en-US" sz="1400" b="1" i="1" smtClean="0">
                           <a:ln/>
                           <a:solidFill>
                             <a:srgbClr val="333333"/>
@@ -3802,7 +3815,7 @@
                       </m:r>
                     </m:oMath>
                   </a14:m>
-                  <a:endParaRPr lang="en-US" sz="1200" b="1" dirty="0">
+                  <a:endParaRPr lang="en-US" sz="1400" b="1" dirty="0">
                     <a:ln/>
                     <a:solidFill>
                       <a:srgbClr val="333333"/>
@@ -3833,8 +3846,8 @@
               </p:nvSpPr>
               <p:spPr>
                 <a:xfrm rot="16200000">
-                  <a:off x="118323" y="4810004"/>
-                  <a:ext cx="2325871" cy="253916"/>
+                  <a:off x="-54190" y="4786862"/>
+                  <a:ext cx="2670897" cy="284693"/>
                 </a:xfrm>
                 <a:prstGeom prst="rect">
                   <a:avLst/>
@@ -3842,7 +3855,7 @@
                 <a:blipFill>
                   <a:blip r:embed="rId4"/>
                   <a:stretch>
-                    <a:fillRect l="-4762" r="-23810" b="-543"/>
+                    <a:fillRect l="-8333" r="-25000" b="-1422"/>
                   </a:stretch>
                 </a:blipFill>
               </p:spPr>
@@ -3892,7 +3905,7 @@
             </a:bodyPr>
             <a:lstStyle/>
             <a:p>
-              <a:pPr algn="l"/>
+              <a:pPr algn="ctr"/>
               <a:r>
                 <a:rPr lang="en-US" b="1" dirty="0">
                   <a:ln/>
@@ -3904,7 +3917,7 @@
                   <a:sym typeface="Arial"/>
                   <a:rtl val="0"/>
                 </a:rPr>
-                <a:t>Average emissions factors at different temporal resolution</a:t>
+                <a:t>AER of different temporal resolutions at CAISO</a:t>
               </a:r>
             </a:p>
           </p:txBody>
@@ -4068,7 +4081,7 @@
             </p:nvSpPr>
             <p:spPr>
               <a:xfrm>
-                <a:off x="1158583" y="2547812"/>
+                <a:off x="1179530" y="2547812"/>
                 <a:ext cx="417217" cy="417217"/>
               </a:xfrm>
               <a:custGeom>
@@ -4241,10 +4254,10 @@
           </p:nvGrpSpPr>
           <p:grpSpPr>
             <a:xfrm>
-              <a:off x="2679148" y="802876"/>
-              <a:ext cx="2085875" cy="2189092"/>
-              <a:chOff x="3054343" y="468636"/>
-              <a:chExt cx="2085875" cy="2189092"/>
+              <a:off x="2664158" y="739078"/>
+              <a:ext cx="2100865" cy="2268279"/>
+              <a:chOff x="3039353" y="404838"/>
+              <a:chExt cx="2100865" cy="2268279"/>
             </a:xfrm>
           </p:grpSpPr>
           <p:grpSp>
@@ -4261,10 +4274,10 @@
             </p:nvGrpSpPr>
             <p:grpSpPr>
               <a:xfrm>
-                <a:off x="3058588" y="468636"/>
-                <a:ext cx="1792510" cy="2189092"/>
-                <a:chOff x="645836" y="124490"/>
-                <a:chExt cx="2589967" cy="3162985"/>
+                <a:off x="3043598" y="404838"/>
+                <a:ext cx="1951772" cy="2268279"/>
+                <a:chOff x="624178" y="32312"/>
+                <a:chExt cx="2820082" cy="3277399"/>
               </a:xfrm>
             </p:grpSpPr>
             <p:sp>
@@ -4281,8 +4294,8 @@
               </p:nvSpPr>
               <p:spPr>
                 <a:xfrm>
-                  <a:off x="724599" y="2797935"/>
-                  <a:ext cx="302027" cy="322409"/>
+                  <a:off x="702941" y="2787105"/>
+                  <a:ext cx="313608" cy="344644"/>
                 </a:xfrm>
                 <a:prstGeom prst="rect">
                   <a:avLst/>
@@ -4300,7 +4313,7 @@
                 <a:p>
                   <a:pPr algn="l"/>
                   <a:r>
-                    <a:rPr lang="en-US" sz="1000" dirty="0">
+                    <a:rPr lang="en-US" sz="1100" dirty="0">
                       <a:ln/>
                       <a:solidFill>
                         <a:srgbClr val="4D4D4D"/>
@@ -4311,54 +4324,6 @@
                       <a:rtl val="0"/>
                     </a:rPr>
                     <a:t>0</a:t>
-                  </a:r>
-                </a:p>
-              </p:txBody>
-            </p:sp>
-            <p:sp>
-              <p:nvSpPr>
-                <p:cNvPr id="55" name="TextBox 54">
-                  <a:extLst>
-                    <a:ext uri="{FF2B5EF4-FFF2-40B4-BE49-F238E27FC236}">
-                      <a16:creationId xmlns:a16="http://schemas.microsoft.com/office/drawing/2014/main" id="{B7D33DF3-F109-2FA6-45BB-1D8CE2BE919A}"/>
-                    </a:ext>
-                  </a:extLst>
-                </p:cNvPr>
-                <p:cNvSpPr txBox="1"/>
-                <p:nvPr/>
-              </p:nvSpPr>
-              <p:spPr>
-                <a:xfrm>
-                  <a:off x="677021" y="2380729"/>
-                  <a:ext cx="403937" cy="322409"/>
-                </a:xfrm>
-                <a:prstGeom prst="rect">
-                  <a:avLst/>
-                </a:prstGeom>
-                <a:noFill/>
-              </p:spPr>
-              <p:txBody>
-                <a:bodyPr rot="0" spcFirstLastPara="0" vertOverflow="overflow" horzOverflow="overflow" vert="horz" wrap="none" lIns="68580" tIns="34290" rIns="68580" bIns="34290" numCol="1" spcCol="0" rtlCol="0" fromWordArt="0" anchor="t" anchorCtr="0" forceAA="0" compatLnSpc="1">
-                  <a:prstTxWarp prst="textNoShape">
-                    <a:avLst/>
-                  </a:prstTxWarp>
-                  <a:spAutoFit/>
-                </a:bodyPr>
-                <a:lstStyle/>
-                <a:p>
-                  <a:pPr algn="l"/>
-                  <a:r>
-                    <a:rPr lang="en-US" sz="1000" dirty="0">
-                      <a:ln/>
-                      <a:solidFill>
-                        <a:srgbClr val="4D4D4D"/>
-                      </a:solidFill>
-                      <a:latin typeface="Arial"/>
-                      <a:cs typeface="Arial"/>
-                      <a:sym typeface="Arial"/>
-                      <a:rtl val="0"/>
-                    </a:rPr>
-                    <a:t>50</a:t>
                   </a:r>
                 </a:p>
               </p:txBody>
@@ -4377,8 +4342,8 @@
               </p:nvSpPr>
               <p:spPr>
                 <a:xfrm>
-                  <a:off x="645836" y="1968469"/>
-                  <a:ext cx="505848" cy="322409"/>
+                  <a:off x="624178" y="1957640"/>
+                  <a:ext cx="540590" cy="344644"/>
                 </a:xfrm>
                 <a:prstGeom prst="rect">
                   <a:avLst/>
@@ -4396,7 +4361,7 @@
                 <a:p>
                   <a:pPr algn="l"/>
                   <a:r>
-                    <a:rPr lang="en-US" sz="1000" dirty="0">
+                    <a:rPr lang="en-US" sz="1100" dirty="0">
                       <a:ln/>
                       <a:solidFill>
                         <a:srgbClr val="4D4D4D"/>
@@ -4407,54 +4372,6 @@
                       <a:rtl val="0"/>
                     </a:rPr>
                     <a:t>100</a:t>
-                  </a:r>
-                </a:p>
-              </p:txBody>
-            </p:sp>
-            <p:sp>
-              <p:nvSpPr>
-                <p:cNvPr id="57" name="TextBox 56">
-                  <a:extLst>
-                    <a:ext uri="{FF2B5EF4-FFF2-40B4-BE49-F238E27FC236}">
-                      <a16:creationId xmlns:a16="http://schemas.microsoft.com/office/drawing/2014/main" id="{91B4538D-2A2C-D5B1-2630-F32B3E8EF195}"/>
-                    </a:ext>
-                  </a:extLst>
-                </p:cNvPr>
-                <p:cNvSpPr txBox="1"/>
-                <p:nvPr/>
-              </p:nvSpPr>
-              <p:spPr>
-                <a:xfrm>
-                  <a:off x="645840" y="1566871"/>
-                  <a:ext cx="505848" cy="322409"/>
-                </a:xfrm>
-                <a:prstGeom prst="rect">
-                  <a:avLst/>
-                </a:prstGeom>
-                <a:noFill/>
-              </p:spPr>
-              <p:txBody>
-                <a:bodyPr rot="0" spcFirstLastPara="0" vertOverflow="overflow" horzOverflow="overflow" vert="horz" wrap="none" lIns="68580" tIns="34290" rIns="68580" bIns="34290" numCol="1" spcCol="0" rtlCol="0" fromWordArt="0" anchor="t" anchorCtr="0" forceAA="0" compatLnSpc="1">
-                  <a:prstTxWarp prst="textNoShape">
-                    <a:avLst/>
-                  </a:prstTxWarp>
-                  <a:spAutoFit/>
-                </a:bodyPr>
-                <a:lstStyle/>
-                <a:p>
-                  <a:pPr algn="l"/>
-                  <a:r>
-                    <a:rPr lang="en-US" sz="1000" dirty="0">
-                      <a:ln/>
-                      <a:solidFill>
-                        <a:srgbClr val="4D4D4D"/>
-                      </a:solidFill>
-                      <a:latin typeface="Arial"/>
-                      <a:cs typeface="Arial"/>
-                      <a:sym typeface="Arial"/>
-                      <a:rtl val="0"/>
-                    </a:rPr>
-                    <a:t>150</a:t>
                   </a:r>
                 </a:p>
               </p:txBody>
@@ -4473,8 +4390,8 @@
               </p:nvSpPr>
               <p:spPr>
                 <a:xfrm>
-                  <a:off x="645840" y="1154196"/>
-                  <a:ext cx="505848" cy="322409"/>
+                  <a:off x="624182" y="1143367"/>
+                  <a:ext cx="540590" cy="344644"/>
                 </a:xfrm>
                 <a:prstGeom prst="rect">
                   <a:avLst/>
@@ -4492,7 +4409,7 @@
                 <a:p>
                   <a:pPr algn="l"/>
                   <a:r>
-                    <a:rPr lang="en-US" sz="1000" dirty="0">
+                    <a:rPr lang="en-US" sz="1100" dirty="0">
                       <a:ln/>
                       <a:solidFill>
                         <a:srgbClr val="4D4D4D"/>
@@ -4503,54 +4420,6 @@
                       <a:rtl val="0"/>
                     </a:rPr>
                     <a:t>200</a:t>
-                  </a:r>
-                </a:p>
-              </p:txBody>
-            </p:sp>
-            <p:sp>
-              <p:nvSpPr>
-                <p:cNvPr id="59" name="TextBox 58">
-                  <a:extLst>
-                    <a:ext uri="{FF2B5EF4-FFF2-40B4-BE49-F238E27FC236}">
-                      <a16:creationId xmlns:a16="http://schemas.microsoft.com/office/drawing/2014/main" id="{42379E6C-C4FC-EAAE-DC3B-F3B3DE5CD496}"/>
-                    </a:ext>
-                  </a:extLst>
-                </p:cNvPr>
-                <p:cNvSpPr txBox="1"/>
-                <p:nvPr/>
-              </p:nvSpPr>
-              <p:spPr>
-                <a:xfrm>
-                  <a:off x="645840" y="741521"/>
-                  <a:ext cx="505848" cy="322409"/>
-                </a:xfrm>
-                <a:prstGeom prst="rect">
-                  <a:avLst/>
-                </a:prstGeom>
-                <a:noFill/>
-              </p:spPr>
-              <p:txBody>
-                <a:bodyPr rot="0" spcFirstLastPara="0" vertOverflow="overflow" horzOverflow="overflow" vert="horz" wrap="none" lIns="68580" tIns="34290" rIns="68580" bIns="34290" numCol="1" spcCol="0" rtlCol="0" fromWordArt="0" anchor="t" anchorCtr="0" forceAA="0" compatLnSpc="1">
-                  <a:prstTxWarp prst="textNoShape">
-                    <a:avLst/>
-                  </a:prstTxWarp>
-                  <a:spAutoFit/>
-                </a:bodyPr>
-                <a:lstStyle/>
-                <a:p>
-                  <a:pPr algn="l"/>
-                  <a:r>
-                    <a:rPr lang="en-US" sz="1000" dirty="0">
-                      <a:ln/>
-                      <a:solidFill>
-                        <a:srgbClr val="4D4D4D"/>
-                      </a:solidFill>
-                      <a:latin typeface="Arial"/>
-                      <a:cs typeface="Arial"/>
-                      <a:sym typeface="Arial"/>
-                      <a:rtl val="0"/>
-                    </a:rPr>
-                    <a:t>250</a:t>
                   </a:r>
                 </a:p>
               </p:txBody>
@@ -4569,8 +4438,8 @@
               </p:nvSpPr>
               <p:spPr>
                 <a:xfrm>
-                  <a:off x="1517524" y="2965066"/>
-                  <a:ext cx="607758" cy="322409"/>
+                  <a:off x="1486797" y="2965067"/>
+                  <a:ext cx="654081" cy="344644"/>
                 </a:xfrm>
                 <a:prstGeom prst="rect">
                   <a:avLst/>
@@ -4588,7 +4457,7 @@
                 <a:p>
                   <a:pPr algn="l"/>
                   <a:r>
-                    <a:rPr lang="en-US" sz="1000" dirty="0">
+                    <a:rPr lang="en-US" sz="1100" dirty="0">
                       <a:ln/>
                       <a:solidFill>
                         <a:srgbClr val="4D4D4D"/>
@@ -4617,8 +4486,8 @@
               </p:nvSpPr>
               <p:spPr>
                 <a:xfrm>
-                  <a:off x="2573259" y="2965065"/>
-                  <a:ext cx="607758" cy="322409"/>
+                  <a:off x="2542531" y="2965064"/>
+                  <a:ext cx="654081" cy="344644"/>
                 </a:xfrm>
                 <a:prstGeom prst="rect">
                   <a:avLst/>
@@ -4636,7 +4505,7 @@
                 <a:p>
                   <a:pPr algn="l"/>
                   <a:r>
-                    <a:rPr lang="en-US" sz="1000" dirty="0">
+                    <a:rPr lang="en-US" sz="1100" dirty="0">
                       <a:ln/>
                       <a:solidFill>
                         <a:srgbClr val="4D4D4D"/>
@@ -4665,8 +4534,8 @@
               </p:nvSpPr>
               <p:spPr>
                 <a:xfrm>
-                  <a:off x="1245302" y="124490"/>
-                  <a:ext cx="1990501" cy="366879"/>
+                  <a:off x="932625" y="32312"/>
+                  <a:ext cx="2511635" cy="411348"/>
                 </a:xfrm>
                 <a:prstGeom prst="rect">
                   <a:avLst/>
@@ -4684,7 +4553,7 @@
                 <a:p>
                   <a:pPr algn="l"/>
                   <a:r>
-                    <a:rPr lang="en-US" sz="1200" b="1" dirty="0">
+                    <a:rPr lang="en-US" sz="1400" b="1" dirty="0">
                       <a:ln/>
                       <a:solidFill>
                         <a:srgbClr val="333333"/>
@@ -4694,7 +4563,7 @@
                       <a:sym typeface="Arial"/>
                       <a:rtl val="0"/>
                     </a:rPr>
-                    <a:t>Annual averaged</a:t>
+                    <a:t>Annual average (1)</a:t>
                   </a:r>
                 </a:p>
               </p:txBody>
@@ -4714,10 +4583,10 @@
             </p:nvGrpSpPr>
             <p:grpSpPr>
               <a:xfrm>
-                <a:off x="3054343" y="611542"/>
-                <a:ext cx="2085875" cy="1821828"/>
-                <a:chOff x="3054343" y="611542"/>
-                <a:chExt cx="2085875" cy="1821828"/>
+                <a:off x="3039353" y="604047"/>
+                <a:ext cx="2100865" cy="1829323"/>
+                <a:chOff x="3039353" y="604047"/>
+                <a:chExt cx="2100865" cy="1829323"/>
               </a:xfrm>
             </p:grpSpPr>
             <p:grpSp>
@@ -4805,69 +4674,6 @@
               </p:sp>
               <p:sp>
                 <p:nvSpPr>
-                  <p:cNvPr id="4" name="Freeform 3">
-                    <a:extLst>
-                      <a:ext uri="{FF2B5EF4-FFF2-40B4-BE49-F238E27FC236}">
-                        <a16:creationId xmlns:a16="http://schemas.microsoft.com/office/drawing/2014/main" id="{BF2A5572-4D7A-1F53-0779-7ADF88249B38}"/>
-                      </a:ext>
-                    </a:extLst>
-                  </p:cNvPr>
-                  <p:cNvSpPr/>
-                  <p:nvPr/>
-                </p:nvSpPr>
-                <p:spPr>
-                  <a:xfrm>
-                    <a:off x="2416116" y="2835374"/>
-                    <a:ext cx="2696444" cy="5261"/>
-                  </a:xfrm>
-                  <a:custGeom>
-                    <a:avLst/>
-                    <a:gdLst>
-                      <a:gd name="connsiteX0" fmla="*/ 0 w 2696444"/>
-                      <a:gd name="connsiteY0" fmla="*/ 0 h 5261"/>
-                      <a:gd name="connsiteX1" fmla="*/ 2696445 w 2696444"/>
-                      <a:gd name="connsiteY1" fmla="*/ 0 h 5261"/>
-                    </a:gdLst>
-                    <a:ahLst/>
-                    <a:cxnLst>
-                      <a:cxn ang="0">
-                        <a:pos x="connsiteX0" y="connsiteY0"/>
-                      </a:cxn>
-                      <a:cxn ang="0">
-                        <a:pos x="connsiteX1" y="connsiteY1"/>
-                      </a:cxn>
-                    </a:cxnLst>
-                    <a:rect l="l" t="t" r="r" b="b"/>
-                    <a:pathLst>
-                      <a:path w="2696444" h="5261">
-                        <a:moveTo>
-                          <a:pt x="0" y="0"/>
-                        </a:moveTo>
-                        <a:lnTo>
-                          <a:pt x="2696445" y="0"/>
-                        </a:lnTo>
-                      </a:path>
-                    </a:pathLst>
-                  </a:custGeom>
-                  <a:noFill/>
-                  <a:ln w="2787" cap="flat">
-                    <a:solidFill>
-                      <a:srgbClr val="CCCCCC"/>
-                    </a:solidFill>
-                    <a:prstDash val="solid"/>
-                    <a:round/>
-                  </a:ln>
-                </p:spPr>
-                <p:txBody>
-                  <a:bodyPr rtlCol="0" anchor="ctr"/>
-                  <a:lstStyle/>
-                  <a:p>
-                    <a:endParaRPr lang="en-US"/>
-                  </a:p>
-                </p:txBody>
-              </p:sp>
-              <p:sp>
-                <p:nvSpPr>
                   <p:cNvPr id="5" name="Freeform 4">
                     <a:extLst>
                       <a:ext uri="{FF2B5EF4-FFF2-40B4-BE49-F238E27FC236}">
@@ -4881,69 +4687,6 @@
                 <p:spPr>
                   <a:xfrm>
                     <a:off x="2416116" y="2405128"/>
-                    <a:ext cx="2696444" cy="5261"/>
-                  </a:xfrm>
-                  <a:custGeom>
-                    <a:avLst/>
-                    <a:gdLst>
-                      <a:gd name="connsiteX0" fmla="*/ 0 w 2696444"/>
-                      <a:gd name="connsiteY0" fmla="*/ 0 h 5261"/>
-                      <a:gd name="connsiteX1" fmla="*/ 2696445 w 2696444"/>
-                      <a:gd name="connsiteY1" fmla="*/ 0 h 5261"/>
-                    </a:gdLst>
-                    <a:ahLst/>
-                    <a:cxnLst>
-                      <a:cxn ang="0">
-                        <a:pos x="connsiteX0" y="connsiteY0"/>
-                      </a:cxn>
-                      <a:cxn ang="0">
-                        <a:pos x="connsiteX1" y="connsiteY1"/>
-                      </a:cxn>
-                    </a:cxnLst>
-                    <a:rect l="l" t="t" r="r" b="b"/>
-                    <a:pathLst>
-                      <a:path w="2696444" h="5261">
-                        <a:moveTo>
-                          <a:pt x="0" y="0"/>
-                        </a:moveTo>
-                        <a:lnTo>
-                          <a:pt x="2696445" y="0"/>
-                        </a:lnTo>
-                      </a:path>
-                    </a:pathLst>
-                  </a:custGeom>
-                  <a:noFill/>
-                  <a:ln w="2787" cap="flat">
-                    <a:solidFill>
-                      <a:srgbClr val="CCCCCC"/>
-                    </a:solidFill>
-                    <a:prstDash val="solid"/>
-                    <a:round/>
-                  </a:ln>
-                </p:spPr>
-                <p:txBody>
-                  <a:bodyPr rtlCol="0" anchor="ctr"/>
-                  <a:lstStyle/>
-                  <a:p>
-                    <a:endParaRPr lang="en-US"/>
-                  </a:p>
-                </p:txBody>
-              </p:sp>
-              <p:sp>
-                <p:nvSpPr>
-                  <p:cNvPr id="6" name="Freeform 5">
-                    <a:extLst>
-                      <a:ext uri="{FF2B5EF4-FFF2-40B4-BE49-F238E27FC236}">
-                        <a16:creationId xmlns:a16="http://schemas.microsoft.com/office/drawing/2014/main" id="{4397AC49-B314-B3C3-445E-C255FE7DBAC6}"/>
-                      </a:ext>
-                    </a:extLst>
-                  </p:cNvPr>
-                  <p:cNvSpPr/>
-                  <p:nvPr/>
-                </p:nvSpPr>
-                <p:spPr>
-                  <a:xfrm>
-                    <a:off x="2416116" y="1974882"/>
                     <a:ext cx="2696444" cy="5261"/>
                   </a:xfrm>
                   <a:custGeom>
@@ -5007,69 +4750,6 @@
                 <p:spPr>
                   <a:xfrm>
                     <a:off x="2416116" y="1544636"/>
-                    <a:ext cx="2696444" cy="5261"/>
-                  </a:xfrm>
-                  <a:custGeom>
-                    <a:avLst/>
-                    <a:gdLst>
-                      <a:gd name="connsiteX0" fmla="*/ 0 w 2696444"/>
-                      <a:gd name="connsiteY0" fmla="*/ 0 h 5261"/>
-                      <a:gd name="connsiteX1" fmla="*/ 2696445 w 2696444"/>
-                      <a:gd name="connsiteY1" fmla="*/ 0 h 5261"/>
-                    </a:gdLst>
-                    <a:ahLst/>
-                    <a:cxnLst>
-                      <a:cxn ang="0">
-                        <a:pos x="connsiteX0" y="connsiteY0"/>
-                      </a:cxn>
-                      <a:cxn ang="0">
-                        <a:pos x="connsiteX1" y="connsiteY1"/>
-                      </a:cxn>
-                    </a:cxnLst>
-                    <a:rect l="l" t="t" r="r" b="b"/>
-                    <a:pathLst>
-                      <a:path w="2696444" h="5261">
-                        <a:moveTo>
-                          <a:pt x="0" y="0"/>
-                        </a:moveTo>
-                        <a:lnTo>
-                          <a:pt x="2696445" y="0"/>
-                        </a:lnTo>
-                      </a:path>
-                    </a:pathLst>
-                  </a:custGeom>
-                  <a:noFill/>
-                  <a:ln w="2787" cap="flat">
-                    <a:solidFill>
-                      <a:srgbClr val="CCCCCC"/>
-                    </a:solidFill>
-                    <a:prstDash val="solid"/>
-                    <a:round/>
-                  </a:ln>
-                </p:spPr>
-                <p:txBody>
-                  <a:bodyPr rtlCol="0" anchor="ctr"/>
-                  <a:lstStyle/>
-                  <a:p>
-                    <a:endParaRPr lang="en-US"/>
-                  </a:p>
-                </p:txBody>
-              </p:sp>
-              <p:sp>
-                <p:nvSpPr>
-                  <p:cNvPr id="8" name="Freeform 7">
-                    <a:extLst>
-                      <a:ext uri="{FF2B5EF4-FFF2-40B4-BE49-F238E27FC236}">
-                        <a16:creationId xmlns:a16="http://schemas.microsoft.com/office/drawing/2014/main" id="{FE1A3A38-A45C-E2E8-9792-A35B2EDE4681}"/>
-                      </a:ext>
-                    </a:extLst>
-                  </p:cNvPr>
-                  <p:cNvSpPr/>
-                  <p:nvPr/>
-                </p:nvSpPr>
-                <p:spPr>
-                  <a:xfrm>
-                    <a:off x="2416116" y="1114389"/>
                     <a:ext cx="2696444" cy="5261"/>
                   </a:xfrm>
                   <a:custGeom>
@@ -5358,8 +5038,8 @@
               </p:nvSpPr>
               <p:spPr>
                 <a:xfrm>
-                  <a:off x="3054343" y="611542"/>
-                  <a:ext cx="350096" cy="223138"/>
+                  <a:off x="3039353" y="604047"/>
+                  <a:ext cx="374141" cy="238527"/>
                 </a:xfrm>
                 <a:prstGeom prst="rect">
                   <a:avLst/>
@@ -5377,7 +5057,7 @@
                 <a:p>
                   <a:pPr algn="l"/>
                   <a:r>
-                    <a:rPr lang="en-US" sz="1000" dirty="0">
+                    <a:rPr lang="en-US" sz="1100" dirty="0">
                       <a:ln/>
                       <a:solidFill>
                         <a:srgbClr val="4D4D4D"/>
@@ -5408,10 +5088,10 @@
           </p:nvGrpSpPr>
           <p:grpSpPr>
             <a:xfrm>
-              <a:off x="5536592" y="785593"/>
-              <a:ext cx="1811859" cy="2197163"/>
-              <a:chOff x="5465226" y="466973"/>
-              <a:chExt cx="1811859" cy="2197163"/>
+              <a:off x="5546912" y="721795"/>
+              <a:ext cx="1833247" cy="2276350"/>
+              <a:chOff x="5475546" y="403175"/>
+              <a:chExt cx="1833247" cy="2276350"/>
             </a:xfrm>
           </p:grpSpPr>
           <p:grpSp>
@@ -5428,10 +5108,10 @@
             </p:nvGrpSpPr>
             <p:grpSpPr>
               <a:xfrm>
-                <a:off x="5465226" y="466973"/>
-                <a:ext cx="1791269" cy="2197163"/>
-                <a:chOff x="4128313" y="148426"/>
-                <a:chExt cx="2588176" cy="3174642"/>
+                <a:off x="5475546" y="403175"/>
+                <a:ext cx="1833247" cy="2276350"/>
+                <a:chOff x="4143216" y="56248"/>
+                <a:chExt cx="2648828" cy="3289055"/>
               </a:xfrm>
             </p:grpSpPr>
             <p:sp>
@@ -5448,8 +5128,8 @@
               </p:nvSpPr>
               <p:spPr>
                 <a:xfrm>
-                  <a:off x="4128313" y="2992949"/>
-                  <a:ext cx="702722" cy="322408"/>
+                  <a:off x="4143216" y="2992949"/>
+                  <a:ext cx="755992" cy="344643"/>
                 </a:xfrm>
                 <a:prstGeom prst="rect">
                   <a:avLst/>
@@ -5467,7 +5147,7 @@
                 <a:p>
                   <a:pPr algn="l"/>
                   <a:r>
-                    <a:rPr lang="en-US" sz="1000" dirty="0">
+                    <a:rPr lang="en-US" sz="1100" dirty="0">
                       <a:ln/>
                       <a:solidFill>
                         <a:srgbClr val="4D4D4D"/>
@@ -5497,7 +5177,7 @@
               <p:spPr>
                 <a:xfrm>
                   <a:off x="4715083" y="2992949"/>
-                  <a:ext cx="869484" cy="322408"/>
+                  <a:ext cx="934337" cy="344643"/>
                 </a:xfrm>
                 <a:prstGeom prst="rect">
                   <a:avLst/>
@@ -5515,7 +5195,7 @@
                 <a:p>
                   <a:pPr algn="l"/>
                   <a:r>
-                    <a:rPr lang="en-US" sz="1000" dirty="0">
+                    <a:rPr lang="en-US" sz="1100" dirty="0">
                       <a:ln/>
                       <a:solidFill>
                         <a:srgbClr val="4D4D4D"/>
@@ -5544,8 +5224,8 @@
               </p:nvSpPr>
               <p:spPr>
                 <a:xfrm>
-                  <a:off x="5539383" y="3000660"/>
-                  <a:ext cx="436362" cy="322408"/>
+                  <a:off x="5554747" y="3000660"/>
+                  <a:ext cx="461841" cy="344643"/>
                 </a:xfrm>
                 <a:prstGeom prst="rect">
                   <a:avLst/>
@@ -5563,7 +5243,7 @@
                 <a:p>
                   <a:pPr algn="l"/>
                   <a:r>
-                    <a:rPr lang="en-US" sz="1000" dirty="0">
+                    <a:rPr lang="en-US" sz="1100" dirty="0">
                       <a:ln/>
                       <a:solidFill>
                         <a:srgbClr val="4D4D4D"/>
@@ -5592,8 +5272,8 @@
               </p:nvSpPr>
               <p:spPr>
                 <a:xfrm>
-                  <a:off x="6023031" y="2988176"/>
-                  <a:ext cx="693458" cy="322408"/>
+                  <a:off x="6038394" y="2988176"/>
+                  <a:ext cx="744413" cy="344643"/>
                 </a:xfrm>
                 <a:prstGeom prst="rect">
                   <a:avLst/>
@@ -5611,7 +5291,7 @@
                 <a:p>
                   <a:pPr algn="l"/>
                   <a:r>
-                    <a:rPr lang="en-US" sz="1000" dirty="0">
+                    <a:rPr lang="en-US" sz="1100" dirty="0">
                       <a:ln/>
                       <a:solidFill>
                         <a:srgbClr val="4D4D4D"/>
@@ -5640,8 +5320,8 @@
               </p:nvSpPr>
               <p:spPr>
                 <a:xfrm>
-                  <a:off x="4573896" y="148426"/>
-                  <a:ext cx="2025244" cy="366879"/>
+                  <a:off x="4236400" y="56248"/>
+                  <a:ext cx="2555644" cy="411348"/>
                 </a:xfrm>
                 <a:prstGeom prst="rect">
                   <a:avLst/>
@@ -5659,7 +5339,7 @@
                 <a:p>
                   <a:pPr algn="l"/>
                   <a:r>
-                    <a:rPr lang="en-US" sz="1200" b="1" dirty="0">
+                    <a:rPr lang="en-US" sz="1400" b="1" dirty="0">
                       <a:ln/>
                       <a:solidFill>
                         <a:srgbClr val="333333"/>
@@ -5669,7 +5349,7 @@
                       <a:sym typeface="Arial"/>
                       <a:rtl val="0"/>
                     </a:rPr>
-                    <a:t>Season averaged</a:t>
+                    <a:t>Season average (4)</a:t>
                   </a:r>
                 </a:p>
               </p:txBody>
@@ -5760,69 +5440,6 @@
             </p:sp>
             <p:sp>
               <p:nvSpPr>
-                <p:cNvPr id="17" name="Freeform 16">
-                  <a:extLst>
-                    <a:ext uri="{FF2B5EF4-FFF2-40B4-BE49-F238E27FC236}">
-                      <a16:creationId xmlns:a16="http://schemas.microsoft.com/office/drawing/2014/main" id="{DD56C173-7D73-179E-E384-2094AF873393}"/>
-                    </a:ext>
-                  </a:extLst>
-                </p:cNvPr>
-                <p:cNvSpPr/>
-                <p:nvPr/>
-              </p:nvSpPr>
-              <p:spPr>
-                <a:xfrm>
-                  <a:off x="3252372" y="2929388"/>
-                  <a:ext cx="1792592" cy="3497"/>
-                </a:xfrm>
-                <a:custGeom>
-                  <a:avLst/>
-                  <a:gdLst>
-                    <a:gd name="connsiteX0" fmla="*/ 0 w 1792592"/>
-                    <a:gd name="connsiteY0" fmla="*/ 0 h 3497"/>
-                    <a:gd name="connsiteX1" fmla="*/ 1792592 w 1792592"/>
-                    <a:gd name="connsiteY1" fmla="*/ 0 h 3497"/>
-                  </a:gdLst>
-                  <a:ahLst/>
-                  <a:cxnLst>
-                    <a:cxn ang="0">
-                      <a:pos x="connsiteX0" y="connsiteY0"/>
-                    </a:cxn>
-                    <a:cxn ang="0">
-                      <a:pos x="connsiteX1" y="connsiteY1"/>
-                    </a:cxn>
-                  </a:cxnLst>
-                  <a:rect l="l" t="t" r="r" b="b"/>
-                  <a:pathLst>
-                    <a:path w="1792592" h="3497">
-                      <a:moveTo>
-                        <a:pt x="0" y="0"/>
-                      </a:moveTo>
-                      <a:lnTo>
-                        <a:pt x="1792592" y="0"/>
-                      </a:lnTo>
-                    </a:path>
-                  </a:pathLst>
-                </a:custGeom>
-                <a:noFill/>
-                <a:ln w="1849" cap="flat">
-                  <a:solidFill>
-                    <a:srgbClr val="CCCCCC"/>
-                  </a:solidFill>
-                  <a:prstDash val="solid"/>
-                  <a:round/>
-                </a:ln>
-              </p:spPr>
-              <p:txBody>
-                <a:bodyPr rtlCol="0" anchor="ctr"/>
-                <a:lstStyle/>
-                <a:p>
-                  <a:endParaRPr lang="en-US"/>
-                </a:p>
-              </p:txBody>
-            </p:sp>
-            <p:sp>
-              <p:nvSpPr>
                 <p:cNvPr id="18" name="Freeform 17">
                   <a:extLst>
                     <a:ext uri="{FF2B5EF4-FFF2-40B4-BE49-F238E27FC236}">
@@ -5836,69 +5453,6 @@
               <p:spPr>
                 <a:xfrm>
                   <a:off x="3252372" y="2643361"/>
-                  <a:ext cx="1792592" cy="3497"/>
-                </a:xfrm>
-                <a:custGeom>
-                  <a:avLst/>
-                  <a:gdLst>
-                    <a:gd name="connsiteX0" fmla="*/ 0 w 1792592"/>
-                    <a:gd name="connsiteY0" fmla="*/ 0 h 3497"/>
-                    <a:gd name="connsiteX1" fmla="*/ 1792592 w 1792592"/>
-                    <a:gd name="connsiteY1" fmla="*/ 0 h 3497"/>
-                  </a:gdLst>
-                  <a:ahLst/>
-                  <a:cxnLst>
-                    <a:cxn ang="0">
-                      <a:pos x="connsiteX0" y="connsiteY0"/>
-                    </a:cxn>
-                    <a:cxn ang="0">
-                      <a:pos x="connsiteX1" y="connsiteY1"/>
-                    </a:cxn>
-                  </a:cxnLst>
-                  <a:rect l="l" t="t" r="r" b="b"/>
-                  <a:pathLst>
-                    <a:path w="1792592" h="3497">
-                      <a:moveTo>
-                        <a:pt x="0" y="0"/>
-                      </a:moveTo>
-                      <a:lnTo>
-                        <a:pt x="1792592" y="0"/>
-                      </a:lnTo>
-                    </a:path>
-                  </a:pathLst>
-                </a:custGeom>
-                <a:noFill/>
-                <a:ln w="1849" cap="flat">
-                  <a:solidFill>
-                    <a:srgbClr val="CCCCCC"/>
-                  </a:solidFill>
-                  <a:prstDash val="solid"/>
-                  <a:round/>
-                </a:ln>
-              </p:spPr>
-              <p:txBody>
-                <a:bodyPr rtlCol="0" anchor="ctr"/>
-                <a:lstStyle/>
-                <a:p>
-                  <a:endParaRPr lang="en-US"/>
-                </a:p>
-              </p:txBody>
-            </p:sp>
-            <p:sp>
-              <p:nvSpPr>
-                <p:cNvPr id="19" name="Freeform 18">
-                  <a:extLst>
-                    <a:ext uri="{FF2B5EF4-FFF2-40B4-BE49-F238E27FC236}">
-                      <a16:creationId xmlns:a16="http://schemas.microsoft.com/office/drawing/2014/main" id="{A0CCC784-941C-CDE3-3CF8-67A4A66E70E7}"/>
-                    </a:ext>
-                  </a:extLst>
-                </p:cNvPr>
-                <p:cNvSpPr/>
-                <p:nvPr/>
-              </p:nvSpPr>
-              <p:spPr>
-                <a:xfrm>
-                  <a:off x="3252372" y="2357334"/>
                   <a:ext cx="1792592" cy="3497"/>
                 </a:xfrm>
                 <a:custGeom>
@@ -5962,69 +5516,6 @@
               <p:spPr>
                 <a:xfrm>
                   <a:off x="3252372" y="2071307"/>
-                  <a:ext cx="1792592" cy="3497"/>
-                </a:xfrm>
-                <a:custGeom>
-                  <a:avLst/>
-                  <a:gdLst>
-                    <a:gd name="connsiteX0" fmla="*/ 0 w 1792592"/>
-                    <a:gd name="connsiteY0" fmla="*/ 0 h 3497"/>
-                    <a:gd name="connsiteX1" fmla="*/ 1792592 w 1792592"/>
-                    <a:gd name="connsiteY1" fmla="*/ 0 h 3497"/>
-                  </a:gdLst>
-                  <a:ahLst/>
-                  <a:cxnLst>
-                    <a:cxn ang="0">
-                      <a:pos x="connsiteX0" y="connsiteY0"/>
-                    </a:cxn>
-                    <a:cxn ang="0">
-                      <a:pos x="connsiteX1" y="connsiteY1"/>
-                    </a:cxn>
-                  </a:cxnLst>
-                  <a:rect l="l" t="t" r="r" b="b"/>
-                  <a:pathLst>
-                    <a:path w="1792592" h="3497">
-                      <a:moveTo>
-                        <a:pt x="0" y="0"/>
-                      </a:moveTo>
-                      <a:lnTo>
-                        <a:pt x="1792592" y="0"/>
-                      </a:lnTo>
-                    </a:path>
-                  </a:pathLst>
-                </a:custGeom>
-                <a:noFill/>
-                <a:ln w="1849" cap="flat">
-                  <a:solidFill>
-                    <a:srgbClr val="CCCCCC"/>
-                  </a:solidFill>
-                  <a:prstDash val="solid"/>
-                  <a:round/>
-                </a:ln>
-              </p:spPr>
-              <p:txBody>
-                <a:bodyPr rtlCol="0" anchor="ctr"/>
-                <a:lstStyle/>
-                <a:p>
-                  <a:endParaRPr lang="en-US"/>
-                </a:p>
-              </p:txBody>
-            </p:sp>
-            <p:sp>
-              <p:nvSpPr>
-                <p:cNvPr id="21" name="Freeform 20">
-                  <a:extLst>
-                    <a:ext uri="{FF2B5EF4-FFF2-40B4-BE49-F238E27FC236}">
-                      <a16:creationId xmlns:a16="http://schemas.microsoft.com/office/drawing/2014/main" id="{675F914F-FDCF-A495-626F-0D428B724C28}"/>
-                    </a:ext>
-                  </a:extLst>
-                </p:cNvPr>
-                <p:cNvSpPr/>
-                <p:nvPr/>
-              </p:nvSpPr>
-              <p:spPr>
-                <a:xfrm>
-                  <a:off x="3252372" y="1785280"/>
                   <a:ext cx="1792592" cy="3497"/>
                 </a:xfrm>
                 <a:custGeom>
@@ -6800,10 +6291,10 @@
           </p:nvGrpSpPr>
           <p:grpSpPr>
             <a:xfrm>
-              <a:off x="8058561" y="791349"/>
-              <a:ext cx="1833984" cy="2185652"/>
-              <a:chOff x="7866323" y="470426"/>
-              <a:chExt cx="1833984" cy="2185652"/>
+              <a:off x="7875434" y="727551"/>
+              <a:ext cx="2234980" cy="2264839"/>
+              <a:chOff x="7683196" y="406628"/>
+              <a:chExt cx="2234980" cy="2264839"/>
             </a:xfrm>
           </p:grpSpPr>
           <p:grpSp>
@@ -6820,10 +6311,10 @@
             </p:nvGrpSpPr>
             <p:grpSpPr>
               <a:xfrm>
-                <a:off x="7924454" y="470426"/>
-                <a:ext cx="1717721" cy="2185652"/>
-                <a:chOff x="-1565707" y="3054273"/>
-                <a:chExt cx="2606004" cy="3315913"/>
+                <a:off x="7683196" y="406628"/>
+                <a:ext cx="2234980" cy="2264839"/>
+                <a:chOff x="-1931729" y="2957481"/>
+                <a:chExt cx="3390753" cy="3436053"/>
               </a:xfrm>
             </p:grpSpPr>
             <p:sp>
@@ -6840,8 +6331,8 @@
               </p:nvSpPr>
               <p:spPr>
                 <a:xfrm>
-                  <a:off x="-1356908" y="6030166"/>
-                  <a:ext cx="652459" cy="333525"/>
+                  <a:off x="-1356909" y="6030166"/>
+                  <a:ext cx="698668" cy="356873"/>
                 </a:xfrm>
                 <a:prstGeom prst="rect">
                   <a:avLst/>
@@ -6859,7 +6350,7 @@
                 <a:p>
                   <a:pPr algn="l"/>
                   <a:r>
-                    <a:rPr lang="en-US" sz="1000" dirty="0">
+                    <a:rPr lang="en-US" sz="1100" dirty="0">
                       <a:ln/>
                       <a:solidFill>
                         <a:srgbClr val="4D4D4D"/>
@@ -6888,8 +6379,8 @@
               </p:nvSpPr>
               <p:spPr>
                 <a:xfrm>
-                  <a:off x="-650827" y="6036661"/>
-                  <a:ext cx="759466" cy="333525"/>
+                  <a:off x="-650828" y="6036661"/>
+                  <a:ext cx="817833" cy="356873"/>
                 </a:xfrm>
                 <a:prstGeom prst="rect">
                   <a:avLst/>
@@ -6907,7 +6398,7 @@
                 <a:p>
                   <a:pPr algn="l"/>
                   <a:r>
-                    <a:rPr lang="en-US" sz="1000" dirty="0">
+                    <a:rPr lang="en-US" sz="1100" dirty="0">
                       <a:ln/>
                       <a:solidFill>
                         <a:srgbClr val="4D4D4D"/>
@@ -6936,8 +6427,8 @@
               </p:nvSpPr>
               <p:spPr>
                 <a:xfrm>
-                  <a:off x="162262" y="6025162"/>
-                  <a:ext cx="652459" cy="333525"/>
+                  <a:off x="162263" y="6025163"/>
+                  <a:ext cx="698668" cy="356873"/>
                 </a:xfrm>
                 <a:prstGeom prst="rect">
                   <a:avLst/>
@@ -6955,7 +6446,7 @@
                 <a:p>
                   <a:pPr algn="l"/>
                   <a:r>
-                    <a:rPr lang="en-US" sz="1000" dirty="0">
+                    <a:rPr lang="en-US" sz="1100" dirty="0">
                       <a:ln/>
                       <a:solidFill>
                         <a:srgbClr val="4D4D4D"/>
@@ -6984,8 +6475,8 @@
               </p:nvSpPr>
               <p:spPr>
                 <a:xfrm>
-                  <a:off x="-1565707" y="3054273"/>
-                  <a:ext cx="2606004" cy="380220"/>
+                  <a:off x="-1931729" y="2957481"/>
+                  <a:ext cx="3390753" cy="426912"/>
                 </a:xfrm>
                 <a:prstGeom prst="rect">
                   <a:avLst/>
@@ -7003,7 +6494,7 @@
                 <a:p>
                   <a:pPr algn="l"/>
                   <a:r>
-                    <a:rPr lang="en-US" sz="1200" b="1" dirty="0">
+                    <a:rPr lang="en-US" sz="1400" b="1" dirty="0">
                       <a:ln/>
                       <a:solidFill>
                         <a:srgbClr val="333333"/>
@@ -7013,7 +6504,7 @@
                       <a:sym typeface="Arial"/>
                       <a:rtl val="0"/>
                     </a:rPr>
-                    <a:t>Time-of-day averaged</a:t>
+                    <a:t>Time-of-day average (24)</a:t>
                   </a:r>
                 </a:p>
               </p:txBody>
@@ -7105,69 +6596,6 @@
             </p:sp>
             <p:sp>
               <p:nvSpPr>
-                <p:cNvPr id="69" name="Freeform 68">
-                  <a:extLst>
-                    <a:ext uri="{FF2B5EF4-FFF2-40B4-BE49-F238E27FC236}">
-                      <a16:creationId xmlns:a16="http://schemas.microsoft.com/office/drawing/2014/main" id="{1023174B-C82F-17C9-7296-544697938336}"/>
-                    </a:ext>
-                  </a:extLst>
-                </p:cNvPr>
-                <p:cNvSpPr/>
-                <p:nvPr/>
-              </p:nvSpPr>
-              <p:spPr>
-                <a:xfrm>
-                  <a:off x="3426944" y="3467022"/>
-                  <a:ext cx="2420698" cy="4723"/>
-                </a:xfrm>
-                <a:custGeom>
-                  <a:avLst/>
-                  <a:gdLst>
-                    <a:gd name="connsiteX0" fmla="*/ 0 w 2420698"/>
-                    <a:gd name="connsiteY0" fmla="*/ 0 h 4723"/>
-                    <a:gd name="connsiteX1" fmla="*/ 2420698 w 2420698"/>
-                    <a:gd name="connsiteY1" fmla="*/ 0 h 4723"/>
-                  </a:gdLst>
-                  <a:ahLst/>
-                  <a:cxnLst>
-                    <a:cxn ang="0">
-                      <a:pos x="connsiteX0" y="connsiteY0"/>
-                    </a:cxn>
-                    <a:cxn ang="0">
-                      <a:pos x="connsiteX1" y="connsiteY1"/>
-                    </a:cxn>
-                  </a:cxnLst>
-                  <a:rect l="l" t="t" r="r" b="b"/>
-                  <a:pathLst>
-                    <a:path w="2420698" h="4723">
-                      <a:moveTo>
-                        <a:pt x="0" y="0"/>
-                      </a:moveTo>
-                      <a:lnTo>
-                        <a:pt x="2420698" y="0"/>
-                      </a:lnTo>
-                    </a:path>
-                  </a:pathLst>
-                </a:custGeom>
-                <a:noFill/>
-                <a:ln w="2498" cap="flat">
-                  <a:solidFill>
-                    <a:srgbClr val="CCCCCC"/>
-                  </a:solidFill>
-                  <a:prstDash val="solid"/>
-                  <a:round/>
-                </a:ln>
-              </p:spPr>
-              <p:txBody>
-                <a:bodyPr rtlCol="0" anchor="ctr"/>
-                <a:lstStyle/>
-                <a:p>
-                  <a:endParaRPr lang="en-US"/>
-                </a:p>
-              </p:txBody>
-            </p:sp>
-            <p:sp>
-              <p:nvSpPr>
                 <p:cNvPr id="70" name="Freeform 69">
                   <a:extLst>
                     <a:ext uri="{FF2B5EF4-FFF2-40B4-BE49-F238E27FC236}">
@@ -7181,69 +6609,6 @@
               <p:spPr>
                 <a:xfrm>
                   <a:off x="3426944" y="3080774"/>
-                  <a:ext cx="2420698" cy="4723"/>
-                </a:xfrm>
-                <a:custGeom>
-                  <a:avLst/>
-                  <a:gdLst>
-                    <a:gd name="connsiteX0" fmla="*/ 0 w 2420698"/>
-                    <a:gd name="connsiteY0" fmla="*/ 0 h 4723"/>
-                    <a:gd name="connsiteX1" fmla="*/ 2420698 w 2420698"/>
-                    <a:gd name="connsiteY1" fmla="*/ 0 h 4723"/>
-                  </a:gdLst>
-                  <a:ahLst/>
-                  <a:cxnLst>
-                    <a:cxn ang="0">
-                      <a:pos x="connsiteX0" y="connsiteY0"/>
-                    </a:cxn>
-                    <a:cxn ang="0">
-                      <a:pos x="connsiteX1" y="connsiteY1"/>
-                    </a:cxn>
-                  </a:cxnLst>
-                  <a:rect l="l" t="t" r="r" b="b"/>
-                  <a:pathLst>
-                    <a:path w="2420698" h="4723">
-                      <a:moveTo>
-                        <a:pt x="0" y="0"/>
-                      </a:moveTo>
-                      <a:lnTo>
-                        <a:pt x="2420698" y="0"/>
-                      </a:lnTo>
-                    </a:path>
-                  </a:pathLst>
-                </a:custGeom>
-                <a:noFill/>
-                <a:ln w="2498" cap="flat">
-                  <a:solidFill>
-                    <a:srgbClr val="CCCCCC"/>
-                  </a:solidFill>
-                  <a:prstDash val="solid"/>
-                  <a:round/>
-                </a:ln>
-              </p:spPr>
-              <p:txBody>
-                <a:bodyPr rtlCol="0" anchor="ctr"/>
-                <a:lstStyle/>
-                <a:p>
-                  <a:endParaRPr lang="en-US"/>
-                </a:p>
-              </p:txBody>
-            </p:sp>
-            <p:sp>
-              <p:nvSpPr>
-                <p:cNvPr id="71" name="Freeform 70">
-                  <a:extLst>
-                    <a:ext uri="{FF2B5EF4-FFF2-40B4-BE49-F238E27FC236}">
-                      <a16:creationId xmlns:a16="http://schemas.microsoft.com/office/drawing/2014/main" id="{F782710A-329D-B31D-C0D7-958C034F67B0}"/>
-                    </a:ext>
-                  </a:extLst>
-                </p:cNvPr>
-                <p:cNvSpPr/>
-                <p:nvPr/>
-              </p:nvSpPr>
-              <p:spPr>
-                <a:xfrm>
-                  <a:off x="3426944" y="2694526"/>
                   <a:ext cx="2420698" cy="4723"/>
                 </a:xfrm>
                 <a:custGeom>
@@ -7307,69 +6672,6 @@
               <p:spPr>
                 <a:xfrm>
                   <a:off x="3426944" y="2308278"/>
-                  <a:ext cx="2420698" cy="4723"/>
-                </a:xfrm>
-                <a:custGeom>
-                  <a:avLst/>
-                  <a:gdLst>
-                    <a:gd name="connsiteX0" fmla="*/ 0 w 2420698"/>
-                    <a:gd name="connsiteY0" fmla="*/ 0 h 4723"/>
-                    <a:gd name="connsiteX1" fmla="*/ 2420698 w 2420698"/>
-                    <a:gd name="connsiteY1" fmla="*/ 0 h 4723"/>
-                  </a:gdLst>
-                  <a:ahLst/>
-                  <a:cxnLst>
-                    <a:cxn ang="0">
-                      <a:pos x="connsiteX0" y="connsiteY0"/>
-                    </a:cxn>
-                    <a:cxn ang="0">
-                      <a:pos x="connsiteX1" y="connsiteY1"/>
-                    </a:cxn>
-                  </a:cxnLst>
-                  <a:rect l="l" t="t" r="r" b="b"/>
-                  <a:pathLst>
-                    <a:path w="2420698" h="4723">
-                      <a:moveTo>
-                        <a:pt x="0" y="0"/>
-                      </a:moveTo>
-                      <a:lnTo>
-                        <a:pt x="2420698" y="0"/>
-                      </a:lnTo>
-                    </a:path>
-                  </a:pathLst>
-                </a:custGeom>
-                <a:noFill/>
-                <a:ln w="2498" cap="flat">
-                  <a:solidFill>
-                    <a:srgbClr val="CCCCCC"/>
-                  </a:solidFill>
-                  <a:prstDash val="solid"/>
-                  <a:round/>
-                </a:ln>
-              </p:spPr>
-              <p:txBody>
-                <a:bodyPr rtlCol="0" anchor="ctr"/>
-                <a:lstStyle/>
-                <a:p>
-                  <a:endParaRPr lang="en-US"/>
-                </a:p>
-              </p:txBody>
-            </p:sp>
-            <p:sp>
-              <p:nvSpPr>
-                <p:cNvPr id="74" name="Freeform 73">
-                  <a:extLst>
-                    <a:ext uri="{FF2B5EF4-FFF2-40B4-BE49-F238E27FC236}">
-                      <a16:creationId xmlns:a16="http://schemas.microsoft.com/office/drawing/2014/main" id="{4CC0F8A9-09B8-810B-679A-0F319E374DC3}"/>
-                    </a:ext>
-                  </a:extLst>
-                </p:cNvPr>
-                <p:cNvSpPr/>
-                <p:nvPr/>
-              </p:nvSpPr>
-              <p:spPr>
-                <a:xfrm>
-                  <a:off x="3426944" y="1922030"/>
                   <a:ext cx="2420698" cy="4723"/>
                 </a:xfrm>
                 <a:custGeom>
@@ -7977,10 +7279,10 @@
           </p:nvGrpSpPr>
           <p:grpSpPr>
             <a:xfrm>
-              <a:off x="1478358" y="3234601"/>
-              <a:ext cx="3202953" cy="3283982"/>
-              <a:chOff x="1934918" y="3145493"/>
-              <a:chExt cx="3099922" cy="3178344"/>
+              <a:off x="1478358" y="3170803"/>
+              <a:ext cx="3214574" cy="3384433"/>
+              <a:chOff x="1934918" y="3083747"/>
+              <a:chExt cx="3111169" cy="3275565"/>
             </a:xfrm>
           </p:grpSpPr>
           <p:sp>
@@ -7997,8 +7299,8 @@
             </p:nvSpPr>
             <p:spPr>
               <a:xfrm>
-                <a:off x="2730492" y="4802063"/>
-                <a:ext cx="316250" cy="215600"/>
+                <a:off x="2730492" y="4787556"/>
+                <a:ext cx="343311" cy="242556"/>
               </a:xfrm>
               <a:prstGeom prst="rect">
                 <a:avLst/>
@@ -8016,7 +7318,7 @@
               <a:p>
                 <a:pPr algn="l"/>
                 <a:r>
-                  <a:rPr lang="en-US" sz="1000" b="1" dirty="0">
+                  <a:rPr lang="en-US" sz="1200" b="1" dirty="0">
                     <a:ln/>
                     <a:solidFill>
                       <a:srgbClr val="333333"/>
@@ -8045,8 +7347,8 @@
             </p:nvSpPr>
             <p:spPr>
               <a:xfrm>
-                <a:off x="4134481" y="4802063"/>
-                <a:ext cx="508610" cy="215600"/>
+                <a:off x="4134481" y="4787556"/>
+                <a:ext cx="566718" cy="242556"/>
               </a:xfrm>
               <a:prstGeom prst="rect">
                 <a:avLst/>
@@ -8064,7 +7366,7 @@
               <a:p>
                 <a:pPr algn="l"/>
                 <a:r>
-                  <a:rPr lang="en-US" sz="1000" b="1" dirty="0">
+                  <a:rPr lang="en-US" sz="1200" b="1" dirty="0">
                     <a:ln/>
                     <a:solidFill>
                       <a:srgbClr val="333333"/>
@@ -8093,8 +7395,8 @@
             </p:nvSpPr>
             <p:spPr>
               <a:xfrm>
-                <a:off x="2643648" y="3386328"/>
-                <a:ext cx="523036" cy="215600"/>
+                <a:off x="2643648" y="3371820"/>
+                <a:ext cx="583784" cy="242556"/>
               </a:xfrm>
               <a:prstGeom prst="rect">
                 <a:avLst/>
@@ -8112,7 +7414,7 @@
               <a:p>
                 <a:pPr algn="l"/>
                 <a:r>
-                  <a:rPr lang="en-US" sz="1000" b="1" dirty="0">
+                  <a:rPr lang="en-US" sz="1200" b="1" dirty="0">
                     <a:ln/>
                     <a:solidFill>
                       <a:srgbClr val="333333"/>
@@ -8141,8 +7443,8 @@
             </p:nvSpPr>
             <p:spPr>
               <a:xfrm>
-                <a:off x="4108608" y="3386328"/>
-                <a:ext cx="628835" cy="215600"/>
+                <a:off x="4108608" y="3371820"/>
+                <a:ext cx="704796" cy="242556"/>
               </a:xfrm>
               <a:prstGeom prst="rect">
                 <a:avLst/>
@@ -8160,7 +7462,7 @@
               <a:p>
                 <a:pPr algn="l"/>
                 <a:r>
-                  <a:rPr lang="en-US" sz="1000" b="1" dirty="0">
+                  <a:rPr lang="en-US" sz="1200" b="1" dirty="0">
                     <a:ln/>
                     <a:solidFill>
                       <a:srgbClr val="333333"/>
@@ -8189,8 +7491,8 @@
             </p:nvSpPr>
             <p:spPr>
               <a:xfrm>
-                <a:off x="2323154" y="6108237"/>
-                <a:ext cx="430062" cy="215600"/>
+                <a:off x="2308646" y="6122745"/>
+                <a:ext cx="445706" cy="227662"/>
               </a:xfrm>
               <a:prstGeom prst="rect">
                 <a:avLst/>
@@ -8208,7 +7510,7 @@
               <a:p>
                 <a:pPr algn="l"/>
                 <a:r>
-                  <a:rPr lang="en-US" sz="1000" dirty="0">
+                  <a:rPr lang="en-US" sz="1100" dirty="0">
                     <a:ln/>
                     <a:solidFill>
                       <a:srgbClr val="4D4D4D"/>
@@ -8237,8 +7539,8 @@
             </p:nvSpPr>
             <p:spPr>
               <a:xfrm>
-                <a:off x="2688864" y="6108237"/>
-                <a:ext cx="500594" cy="215600"/>
+                <a:off x="2688864" y="6131649"/>
+                <a:ext cx="521726" cy="227662"/>
               </a:xfrm>
               <a:prstGeom prst="rect">
                 <a:avLst/>
@@ -8256,7 +7558,7 @@
               <a:p>
                 <a:pPr algn="l"/>
                 <a:r>
-                  <a:rPr lang="en-US" sz="1000" dirty="0">
+                  <a:rPr lang="en-US" sz="1100" dirty="0">
                     <a:ln/>
                     <a:solidFill>
                       <a:srgbClr val="4D4D4D"/>
@@ -8285,8 +7587,8 @@
             </p:nvSpPr>
             <p:spPr>
               <a:xfrm>
-                <a:off x="3143555" y="6108237"/>
-                <a:ext cx="430062" cy="215600"/>
+                <a:off x="3143555" y="6131650"/>
+                <a:ext cx="445706" cy="227662"/>
               </a:xfrm>
               <a:prstGeom prst="rect">
                 <a:avLst/>
@@ -8304,7 +7606,7 @@
               <a:p>
                 <a:pPr algn="l"/>
                 <a:r>
-                  <a:rPr lang="en-US" sz="1000" dirty="0">
+                  <a:rPr lang="en-US" sz="1100" dirty="0">
                     <a:ln/>
                     <a:solidFill>
                       <a:srgbClr val="4D4D4D"/>
@@ -8334,7 +7636,7 @@
             <p:spPr>
               <a:xfrm>
                 <a:off x="1981985" y="5998317"/>
-                <a:ext cx="202436" cy="219840"/>
+                <a:ext cx="203681" cy="227662"/>
               </a:xfrm>
               <a:prstGeom prst="rect">
                 <a:avLst/>
@@ -8352,7 +7654,7 @@
               <a:p>
                 <a:pPr algn="l"/>
                 <a:r>
-                  <a:rPr lang="en-US" sz="1000" dirty="0">
+                  <a:rPr lang="en-US" sz="1100" dirty="0">
                     <a:ln/>
                     <a:solidFill>
                       <a:srgbClr val="4D4D4D"/>
@@ -8382,7 +7684,7 @@
             <p:spPr>
               <a:xfrm>
                 <a:off x="1934918" y="5718830"/>
-                <a:ext cx="343500" cy="219840"/>
+                <a:ext cx="355723" cy="227662"/>
               </a:xfrm>
               <a:prstGeom prst="rect">
                 <a:avLst/>
@@ -8400,7 +7702,7 @@
               <a:p>
                 <a:pPr algn="l"/>
                 <a:r>
-                  <a:rPr lang="en-US" sz="1000" dirty="0">
+                  <a:rPr lang="en-US" sz="1100" dirty="0">
                     <a:ln/>
                     <a:solidFill>
                       <a:srgbClr val="4D4D4D"/>
@@ -8430,7 +7732,7 @@
             <p:spPr>
               <a:xfrm>
                 <a:off x="1934918" y="5464526"/>
-                <a:ext cx="343500" cy="219840"/>
+                <a:ext cx="355723" cy="227662"/>
               </a:xfrm>
               <a:prstGeom prst="rect">
                 <a:avLst/>
@@ -8448,7 +7750,7 @@
               <a:p>
                 <a:pPr algn="l"/>
                 <a:r>
-                  <a:rPr lang="en-US" sz="1000" dirty="0">
+                  <a:rPr lang="en-US" sz="1100" dirty="0">
                     <a:ln/>
                     <a:solidFill>
                       <a:srgbClr val="4D4D4D"/>
@@ -8478,7 +7780,7 @@
             <p:spPr>
               <a:xfrm>
                 <a:off x="1934918" y="5193753"/>
-                <a:ext cx="343500" cy="219840"/>
+                <a:ext cx="355723" cy="227662"/>
               </a:xfrm>
               <a:prstGeom prst="rect">
                 <a:avLst/>
@@ -8496,7 +7798,7 @@
               <a:p>
                 <a:pPr algn="l"/>
                 <a:r>
-                  <a:rPr lang="en-US" sz="1000" dirty="0">
+                  <a:rPr lang="en-US" sz="1100" dirty="0">
                     <a:ln/>
                     <a:solidFill>
                       <a:srgbClr val="4D4D4D"/>
@@ -8525,8 +7827,8 @@
             </p:nvSpPr>
             <p:spPr>
               <a:xfrm>
-                <a:off x="2769183" y="3145493"/>
-                <a:ext cx="1789409" cy="250618"/>
+                <a:off x="2451706" y="3083747"/>
+                <a:ext cx="2243823" cy="272343"/>
               </a:xfrm>
               <a:prstGeom prst="rect">
                 <a:avLst/>
@@ -8544,7 +7846,7 @@
               <a:p>
                 <a:pPr algn="l"/>
                 <a:r>
-                  <a:rPr lang="en-US" sz="1200" b="1" dirty="0">
+                  <a:rPr lang="en-US" sz="1400" b="1" dirty="0">
                     <a:ln/>
                     <a:solidFill>
                       <a:srgbClr val="333333"/>
@@ -8554,7 +7856,7 @@
                     <a:sym typeface="Arial"/>
                     <a:rtl val="0"/>
                   </a:rPr>
-                  <a:t>Season-hour averaged</a:t>
+                  <a:t>Season-hour average (96)</a:t>
                 </a:r>
               </a:p>
             </p:txBody>
@@ -11842,7 +11144,7 @@
             <p:spPr>
               <a:xfrm>
                 <a:off x="1934918" y="4926410"/>
-                <a:ext cx="343500" cy="219840"/>
+                <a:ext cx="355723" cy="227662"/>
               </a:xfrm>
               <a:prstGeom prst="rect">
                 <a:avLst/>
@@ -11860,7 +11162,7 @@
               <a:p>
                 <a:pPr algn="l"/>
                 <a:r>
-                  <a:rPr lang="en-US" sz="1000" dirty="0">
+                  <a:rPr lang="en-US" sz="1100" dirty="0">
                     <a:ln/>
                     <a:solidFill>
                       <a:srgbClr val="4D4D4D"/>
@@ -11890,7 +11192,7 @@
             <p:spPr>
               <a:xfrm>
                 <a:off x="2017262" y="4573253"/>
-                <a:ext cx="202436" cy="219840"/>
+                <a:ext cx="203681" cy="227662"/>
               </a:xfrm>
               <a:prstGeom prst="rect">
                 <a:avLst/>
@@ -11908,7 +11210,7 @@
               <a:p>
                 <a:pPr algn="l"/>
                 <a:r>
-                  <a:rPr lang="en-US" sz="1000" dirty="0">
+                  <a:rPr lang="en-US" sz="1100" dirty="0">
                     <a:ln/>
                     <a:solidFill>
                       <a:srgbClr val="4D4D4D"/>
@@ -11938,7 +11240,7 @@
             <p:spPr>
               <a:xfrm>
                 <a:off x="1970195" y="4293766"/>
-                <a:ext cx="343500" cy="219840"/>
+                <a:ext cx="355723" cy="227662"/>
               </a:xfrm>
               <a:prstGeom prst="rect">
                 <a:avLst/>
@@ -11956,7 +11258,7 @@
               <a:p>
                 <a:pPr algn="l"/>
                 <a:r>
-                  <a:rPr lang="en-US" sz="1000" dirty="0">
+                  <a:rPr lang="en-US" sz="1100" dirty="0">
                     <a:ln/>
                     <a:solidFill>
                       <a:srgbClr val="4D4D4D"/>
@@ -11986,7 +11288,7 @@
             <p:spPr>
               <a:xfrm>
                 <a:off x="1970195" y="4039462"/>
-                <a:ext cx="343500" cy="219840"/>
+                <a:ext cx="355723" cy="227662"/>
               </a:xfrm>
               <a:prstGeom prst="rect">
                 <a:avLst/>
@@ -12004,7 +11306,7 @@
               <a:p>
                 <a:pPr algn="l"/>
                 <a:r>
-                  <a:rPr lang="en-US" sz="1000" dirty="0">
+                  <a:rPr lang="en-US" sz="1100" dirty="0">
                     <a:ln/>
                     <a:solidFill>
                       <a:srgbClr val="4D4D4D"/>
@@ -12034,7 +11336,7 @@
             <p:spPr>
               <a:xfrm>
                 <a:off x="1970195" y="3768689"/>
-                <a:ext cx="343500" cy="219840"/>
+                <a:ext cx="355723" cy="227662"/>
               </a:xfrm>
               <a:prstGeom prst="rect">
                 <a:avLst/>
@@ -12052,7 +11354,7 @@
               <a:p>
                 <a:pPr algn="l"/>
                 <a:r>
-                  <a:rPr lang="en-US" sz="1000" dirty="0">
+                  <a:rPr lang="en-US" sz="1100" dirty="0">
                     <a:ln/>
                     <a:solidFill>
                       <a:srgbClr val="4D4D4D"/>
@@ -12082,7 +11384,7 @@
             <p:spPr>
               <a:xfrm>
                 <a:off x="1970195" y="3501346"/>
-                <a:ext cx="343500" cy="219840"/>
+                <a:ext cx="355723" cy="227662"/>
               </a:xfrm>
               <a:prstGeom prst="rect">
                 <a:avLst/>
@@ -12100,7 +11402,7 @@
               <a:p>
                 <a:pPr algn="l"/>
                 <a:r>
-                  <a:rPr lang="en-US" sz="1000" dirty="0">
+                  <a:rPr lang="en-US" sz="1100" dirty="0">
                     <a:ln/>
                     <a:solidFill>
                       <a:srgbClr val="4D4D4D"/>
@@ -12129,8 +11431,8 @@
             </p:nvSpPr>
             <p:spPr>
               <a:xfrm>
-                <a:off x="3772726" y="6108237"/>
-                <a:ext cx="430062" cy="215600"/>
+                <a:off x="3765472" y="6128819"/>
+                <a:ext cx="445706" cy="227662"/>
               </a:xfrm>
               <a:prstGeom prst="rect">
                 <a:avLst/>
@@ -12148,7 +11450,7 @@
               <a:p>
                 <a:pPr algn="l"/>
                 <a:r>
-                  <a:rPr lang="en-US" sz="1000" dirty="0">
+                  <a:rPr lang="en-US" sz="1100" dirty="0">
                     <a:ln/>
                     <a:solidFill>
                       <a:srgbClr val="4D4D4D"/>
@@ -12177,8 +11479,8 @@
             </p:nvSpPr>
             <p:spPr>
               <a:xfrm>
-                <a:off x="4138436" y="6108237"/>
-                <a:ext cx="500594" cy="215600"/>
+                <a:off x="4138436" y="6128819"/>
+                <a:ext cx="521726" cy="227662"/>
               </a:xfrm>
               <a:prstGeom prst="rect">
                 <a:avLst/>
@@ -12196,7 +11498,7 @@
               <a:p>
                 <a:pPr algn="l"/>
                 <a:r>
-                  <a:rPr lang="en-US" sz="1000" dirty="0">
+                  <a:rPr lang="en-US" sz="1100" dirty="0">
                     <a:ln/>
                     <a:solidFill>
                       <a:srgbClr val="4D4D4D"/>
@@ -12225,8 +11527,8 @@
             </p:nvSpPr>
             <p:spPr>
               <a:xfrm>
-                <a:off x="4593127" y="6108237"/>
-                <a:ext cx="430062" cy="215600"/>
+                <a:off x="4600381" y="6128819"/>
+                <a:ext cx="445706" cy="227662"/>
               </a:xfrm>
               <a:prstGeom prst="rect">
                 <a:avLst/>
@@ -12244,7 +11546,7 @@
               <a:p>
                 <a:pPr algn="l"/>
                 <a:r>
-                  <a:rPr lang="en-US" sz="1000" dirty="0">
+                  <a:rPr lang="en-US" sz="1100" dirty="0">
                     <a:ln/>
                     <a:solidFill>
                       <a:srgbClr val="4D4D4D"/>
@@ -12274,10 +11576,10 @@
           </p:nvGrpSpPr>
           <p:grpSpPr>
             <a:xfrm>
-              <a:off x="4906770" y="3225444"/>
-              <a:ext cx="6130928" cy="3326702"/>
-              <a:chOff x="4934022" y="3086117"/>
-              <a:chExt cx="6130928" cy="3326702"/>
+              <a:off x="4906770" y="3161646"/>
+              <a:ext cx="6130928" cy="3423623"/>
+              <a:chOff x="4934022" y="3022319"/>
+              <a:chExt cx="6130928" cy="3423623"/>
             </a:xfrm>
           </p:grpSpPr>
           <p:grpSp>
@@ -12294,10 +11596,10 @@
             </p:nvGrpSpPr>
             <p:grpSpPr>
               <a:xfrm>
-                <a:off x="4970818" y="3086117"/>
-                <a:ext cx="3898424" cy="3326702"/>
-                <a:chOff x="4952299" y="2097339"/>
-                <a:chExt cx="4224576" cy="2585201"/>
+                <a:off x="4970819" y="3022319"/>
+                <a:ext cx="4203796" cy="3420881"/>
+                <a:chOff x="4952299" y="2047761"/>
+                <a:chExt cx="4555494" cy="2658388"/>
               </a:xfrm>
             </p:grpSpPr>
             <p:sp>
@@ -12314,8 +11616,8 @@
               </p:nvSpPr>
               <p:spPr>
                 <a:xfrm>
-                  <a:off x="4952299" y="4491199"/>
-                  <a:ext cx="523218" cy="191340"/>
+                  <a:off x="4952299" y="4502847"/>
+                  <a:ext cx="556224" cy="203299"/>
                 </a:xfrm>
                 <a:prstGeom prst="rect">
                   <a:avLst/>
@@ -12330,7 +11632,7 @@
                 <a:p>
                   <a:pPr algn="l"/>
                   <a:r>
-                    <a:rPr lang="en-US" sz="1000" spc="0" baseline="0" dirty="0">
+                    <a:rPr lang="en-US" sz="1100" spc="0" baseline="0" dirty="0">
                       <a:ln/>
                       <a:solidFill>
                         <a:srgbClr val="4D4D4D"/>
@@ -12359,8 +11661,8 @@
               </p:nvSpPr>
               <p:spPr>
                 <a:xfrm>
-                  <a:off x="5499955" y="4491200"/>
-                  <a:ext cx="523218" cy="191340"/>
+                  <a:off x="5499955" y="4502850"/>
+                  <a:ext cx="556224" cy="203299"/>
                 </a:xfrm>
                 <a:prstGeom prst="rect">
                   <a:avLst/>
@@ -12375,7 +11677,7 @@
                 <a:p>
                   <a:pPr algn="l"/>
                   <a:r>
-                    <a:rPr lang="en-US" sz="1000" spc="0" baseline="0" dirty="0">
+                    <a:rPr lang="en-US" sz="1100" spc="0" baseline="0" dirty="0">
                       <a:ln/>
                       <a:solidFill>
                         <a:srgbClr val="4D4D4D"/>
@@ -12404,8 +11706,8 @@
               </p:nvSpPr>
               <p:spPr>
                 <a:xfrm>
-                  <a:off x="7270913" y="2097339"/>
-                  <a:ext cx="1905962" cy="215258"/>
+                  <a:off x="6939992" y="2047761"/>
+                  <a:ext cx="2567801" cy="239175"/>
                 </a:xfrm>
                 <a:prstGeom prst="rect">
                   <a:avLst/>
@@ -12420,7 +11722,7 @@
                 <a:p>
                   <a:pPr algn="l"/>
                   <a:r>
-                    <a:rPr lang="en-US" sz="1200" b="1" spc="0" baseline="0" dirty="0">
+                    <a:rPr lang="en-US" sz="1400" b="1" spc="0" baseline="0" dirty="0">
                       <a:ln/>
                       <a:solidFill>
                         <a:srgbClr val="333333"/>
@@ -12430,7 +11732,7 @@
                       <a:sym typeface="Arial"/>
                       <a:rtl val="0"/>
                     </a:rPr>
-                    <a:t>Month-hour averaged</a:t>
+                    <a:t>Month-hour average (288)</a:t>
                   </a:r>
                 </a:p>
               </p:txBody>
@@ -22296,8 +21598,8 @@
             </p:nvSpPr>
             <p:spPr>
               <a:xfrm>
-                <a:off x="5291688" y="4805197"/>
-                <a:ext cx="369012" cy="246221"/>
+                <a:off x="5291688" y="4790207"/>
+                <a:ext cx="407484" cy="276999"/>
               </a:xfrm>
               <a:prstGeom prst="rect">
                 <a:avLst/>
@@ -22312,7 +21614,7 @@
               <a:p>
                 <a:pPr algn="l"/>
                 <a:r>
-                  <a:rPr lang="en-US" sz="1000" b="1" spc="0" baseline="0" dirty="0">
+                  <a:rPr lang="en-US" sz="1200" b="1" spc="0" baseline="0" dirty="0">
                     <a:ln/>
                     <a:solidFill>
                       <a:srgbClr val="333333"/>
@@ -22341,8 +21643,8 @@
             </p:nvSpPr>
             <p:spPr>
               <a:xfrm>
-                <a:off x="6305666" y="4805197"/>
-                <a:ext cx="434734" cy="246221"/>
+                <a:off x="6305666" y="4790207"/>
+                <a:ext cx="484428" cy="276999"/>
               </a:xfrm>
               <a:prstGeom prst="rect">
                 <a:avLst/>
@@ -22357,7 +21659,7 @@
               <a:p>
                 <a:pPr algn="l"/>
                 <a:r>
-                  <a:rPr lang="en-US" sz="1000" b="1" spc="0" baseline="0">
+                  <a:rPr lang="en-US" sz="1200" b="1" spc="0" baseline="0">
                     <a:ln/>
                     <a:solidFill>
                       <a:srgbClr val="333333"/>
@@ -22386,8 +21688,8 @@
             </p:nvSpPr>
             <p:spPr>
               <a:xfrm>
-                <a:off x="7334738" y="4805197"/>
-                <a:ext cx="418704" cy="246221"/>
+                <a:off x="7334738" y="4790207"/>
+                <a:ext cx="466794" cy="276999"/>
               </a:xfrm>
               <a:prstGeom prst="rect">
                 <a:avLst/>
@@ -22402,7 +21704,7 @@
               <a:p>
                 <a:pPr algn="l"/>
                 <a:r>
-                  <a:rPr lang="en-US" sz="1000" b="1" spc="0" baseline="0">
+                  <a:rPr lang="en-US" sz="1200" b="1" spc="0" baseline="0">
                     <a:ln/>
                     <a:solidFill>
                       <a:srgbClr val="333333"/>
@@ -22431,8 +21733,8 @@
             </p:nvSpPr>
             <p:spPr>
               <a:xfrm>
-                <a:off x="8365281" y="4805197"/>
-                <a:ext cx="397866" cy="246221"/>
+                <a:off x="8365281" y="4790207"/>
+                <a:ext cx="441146" cy="276999"/>
               </a:xfrm>
               <a:prstGeom prst="rect">
                 <a:avLst/>
@@ -22447,7 +21749,7 @@
               <a:p>
                 <a:pPr algn="l"/>
                 <a:r>
-                  <a:rPr lang="en-US" sz="1000" b="1" spc="0" baseline="0">
+                  <a:rPr lang="en-US" sz="1200" b="1" spc="0" baseline="0">
                     <a:ln/>
                     <a:solidFill>
                       <a:srgbClr val="333333"/>
@@ -22476,8 +21778,8 @@
             </p:nvSpPr>
             <p:spPr>
               <a:xfrm>
-                <a:off x="9386095" y="4805197"/>
-                <a:ext cx="426720" cy="246221"/>
+                <a:off x="9386095" y="4790207"/>
+                <a:ext cx="474810" cy="276999"/>
               </a:xfrm>
               <a:prstGeom prst="rect">
                 <a:avLst/>
@@ -22492,7 +21794,7 @@
               <a:p>
                 <a:pPr algn="l"/>
                 <a:r>
-                  <a:rPr lang="en-US" sz="1000" b="1" spc="0" baseline="0">
+                  <a:rPr lang="en-US" sz="1200" b="1" spc="0" baseline="0">
                     <a:ln/>
                     <a:solidFill>
                       <a:srgbClr val="333333"/>
@@ -22521,8 +21823,8 @@
             </p:nvSpPr>
             <p:spPr>
               <a:xfrm>
-                <a:off x="10413796" y="4805197"/>
-                <a:ext cx="418704" cy="246221"/>
+                <a:off x="10413796" y="4790207"/>
+                <a:ext cx="465192" cy="276999"/>
               </a:xfrm>
               <a:prstGeom prst="rect">
                 <a:avLst/>
@@ -22537,7 +21839,7 @@
               <a:p>
                 <a:pPr algn="l"/>
                 <a:r>
-                  <a:rPr lang="en-US" sz="1000" b="1" spc="0" baseline="0">
+                  <a:rPr lang="en-US" sz="1200" b="1" spc="0" baseline="0" dirty="0">
                     <a:ln/>
                     <a:solidFill>
                       <a:srgbClr val="333333"/>
@@ -22566,8 +21868,8 @@
             </p:nvSpPr>
             <p:spPr>
               <a:xfrm>
-                <a:off x="5284766" y="3363116"/>
-                <a:ext cx="404278" cy="246221"/>
+                <a:off x="5284766" y="3348126"/>
+                <a:ext cx="449162" cy="276999"/>
               </a:xfrm>
               <a:prstGeom prst="rect">
                 <a:avLst/>
@@ -22582,7 +21884,7 @@
               <a:p>
                 <a:pPr algn="l"/>
                 <a:r>
-                  <a:rPr lang="en-US" sz="1000" b="1" spc="0" baseline="0" dirty="0">
+                  <a:rPr lang="en-US" sz="1200" b="1" spc="0" baseline="0" dirty="0">
                     <a:ln/>
                     <a:solidFill>
                       <a:srgbClr val="333333"/>
@@ -22611,8 +21913,8 @@
             </p:nvSpPr>
             <p:spPr>
               <a:xfrm>
-                <a:off x="6309795" y="3363116"/>
-                <a:ext cx="412292" cy="246221"/>
+                <a:off x="6309795" y="3348126"/>
+                <a:ext cx="458780" cy="276999"/>
               </a:xfrm>
               <a:prstGeom prst="rect">
                 <a:avLst/>
@@ -22627,7 +21929,7 @@
               <a:p>
                 <a:pPr algn="l"/>
                 <a:r>
-                  <a:rPr lang="en-US" sz="1000" b="1" spc="0" baseline="0">
+                  <a:rPr lang="en-US" sz="1200" b="1" spc="0" baseline="0">
                     <a:ln/>
                     <a:solidFill>
                       <a:srgbClr val="333333"/>
@@ -22656,8 +21958,8 @@
             </p:nvSpPr>
             <p:spPr>
               <a:xfrm>
-                <a:off x="7336123" y="3363116"/>
-                <a:ext cx="412292" cy="246221"/>
+                <a:off x="7336123" y="3348126"/>
+                <a:ext cx="457176" cy="276999"/>
               </a:xfrm>
               <a:prstGeom prst="rect">
                 <a:avLst/>
@@ -22672,7 +21974,7 @@
               <a:p>
                 <a:pPr algn="l"/>
                 <a:r>
-                  <a:rPr lang="en-US" sz="1000" b="1" spc="0" baseline="0" dirty="0">
+                  <a:rPr lang="en-US" sz="1200" b="1" spc="0" baseline="0" dirty="0">
                     <a:ln/>
                     <a:solidFill>
                       <a:srgbClr val="333333"/>
@@ -22701,8 +22003,8 @@
             </p:nvSpPr>
             <p:spPr>
               <a:xfrm>
-                <a:off x="8363909" y="3363116"/>
-                <a:ext cx="405880" cy="246221"/>
+                <a:off x="8363909" y="3348126"/>
+                <a:ext cx="449162" cy="276999"/>
               </a:xfrm>
               <a:prstGeom prst="rect">
                 <a:avLst/>
@@ -22717,7 +22019,7 @@
               <a:p>
                 <a:pPr algn="l"/>
                 <a:r>
-                  <a:rPr lang="en-US" sz="1000" b="1" spc="0" baseline="0">
+                  <a:rPr lang="en-US" sz="1200" b="1" spc="0" baseline="0">
                     <a:ln/>
                     <a:solidFill>
                       <a:srgbClr val="333333"/>
@@ -22746,8 +22048,8 @@
             </p:nvSpPr>
             <p:spPr>
               <a:xfrm>
-                <a:off x="9384698" y="3363116"/>
-                <a:ext cx="433132" cy="246221"/>
+                <a:off x="9384698" y="3348126"/>
+                <a:ext cx="482824" cy="276999"/>
               </a:xfrm>
               <a:prstGeom prst="rect">
                 <a:avLst/>
@@ -22762,7 +22064,7 @@
               <a:p>
                 <a:pPr algn="l"/>
                 <a:r>
-                  <a:rPr lang="en-US" sz="1000" b="1" spc="0" baseline="0" dirty="0">
+                  <a:rPr lang="en-US" sz="1200" b="1" spc="0" baseline="0" dirty="0">
                     <a:ln/>
                     <a:solidFill>
                       <a:srgbClr val="333333"/>
@@ -22791,8 +22093,8 @@
             </p:nvSpPr>
             <p:spPr>
               <a:xfrm>
-                <a:off x="10415204" y="3363116"/>
-                <a:ext cx="412292" cy="246221"/>
+                <a:off x="10415204" y="3348126"/>
+                <a:ext cx="458780" cy="276999"/>
               </a:xfrm>
               <a:prstGeom prst="rect">
                 <a:avLst/>
@@ -22807,7 +22109,7 @@
               <a:p>
                 <a:pPr algn="l"/>
                 <a:r>
-                  <a:rPr lang="en-US" sz="1000" b="1" spc="0" baseline="0">
+                  <a:rPr lang="en-US" sz="1200" b="1" spc="0" baseline="0">
                     <a:ln/>
                     <a:solidFill>
                       <a:srgbClr val="333333"/>
@@ -22836,8 +22138,8 @@
             </p:nvSpPr>
             <p:spPr>
               <a:xfrm>
-                <a:off x="5991572" y="6143142"/>
-                <a:ext cx="482824" cy="246221"/>
+                <a:off x="5991572" y="6175846"/>
+                <a:ext cx="513282" cy="261610"/>
               </a:xfrm>
               <a:prstGeom prst="rect">
                 <a:avLst/>
@@ -22852,7 +22154,7 @@
               <a:p>
                 <a:pPr algn="l"/>
                 <a:r>
-                  <a:rPr lang="en-US" sz="1000" spc="0" baseline="0" dirty="0">
+                  <a:rPr lang="en-US" sz="1100" spc="0" baseline="0" dirty="0">
                     <a:ln/>
                     <a:solidFill>
                       <a:srgbClr val="4D4D4D"/>
@@ -22881,8 +22183,8 @@
             </p:nvSpPr>
             <p:spPr>
               <a:xfrm>
-                <a:off x="6496947" y="6143143"/>
-                <a:ext cx="482824" cy="246221"/>
+                <a:off x="6496947" y="6171480"/>
+                <a:ext cx="513282" cy="261610"/>
               </a:xfrm>
               <a:prstGeom prst="rect">
                 <a:avLst/>
@@ -22897,7 +22199,7 @@
               <a:p>
                 <a:pPr algn="l"/>
                 <a:r>
-                  <a:rPr lang="en-US" sz="1000" spc="0" baseline="0" dirty="0">
+                  <a:rPr lang="en-US" sz="1100" spc="0" baseline="0" dirty="0">
                     <a:ln/>
                     <a:solidFill>
                       <a:srgbClr val="4D4D4D"/>
@@ -22926,8 +22228,8 @@
             </p:nvSpPr>
             <p:spPr>
               <a:xfrm>
-                <a:off x="7001637" y="6160558"/>
-                <a:ext cx="482824" cy="246221"/>
+                <a:off x="7001637" y="6175548"/>
+                <a:ext cx="513282" cy="261610"/>
               </a:xfrm>
               <a:prstGeom prst="rect">
                 <a:avLst/>
@@ -22942,7 +22244,7 @@
               <a:p>
                 <a:pPr algn="l"/>
                 <a:r>
-                  <a:rPr lang="en-US" sz="1000" spc="0" baseline="0" dirty="0">
+                  <a:rPr lang="en-US" sz="1100" spc="0" baseline="0" dirty="0">
                     <a:ln/>
                     <a:solidFill>
                       <a:srgbClr val="4D4D4D"/>
@@ -22971,8 +22273,8 @@
             </p:nvSpPr>
             <p:spPr>
               <a:xfrm>
-                <a:off x="7507012" y="6160559"/>
-                <a:ext cx="482824" cy="246221"/>
+                <a:off x="7507012" y="6175549"/>
+                <a:ext cx="513282" cy="261610"/>
               </a:xfrm>
               <a:prstGeom prst="rect">
                 <a:avLst/>
@@ -22987,7 +22289,7 @@
               <a:p>
                 <a:pPr algn="l"/>
                 <a:r>
-                  <a:rPr lang="en-US" sz="1000" spc="0" baseline="0" dirty="0">
+                  <a:rPr lang="en-US" sz="1100" spc="0" baseline="0" dirty="0">
                     <a:ln/>
                     <a:solidFill>
                       <a:srgbClr val="4D4D4D"/>
@@ -23016,8 +22318,8 @@
             </p:nvSpPr>
             <p:spPr>
               <a:xfrm>
-                <a:off x="8014606" y="6143142"/>
-                <a:ext cx="482824" cy="246221"/>
+                <a:off x="8014606" y="6184332"/>
+                <a:ext cx="513282" cy="261610"/>
               </a:xfrm>
               <a:prstGeom prst="rect">
                 <a:avLst/>
@@ -23032,7 +22334,7 @@
               <a:p>
                 <a:pPr algn="l"/>
                 <a:r>
-                  <a:rPr lang="en-US" sz="1000" spc="0" baseline="0" dirty="0">
+                  <a:rPr lang="en-US" sz="1100" spc="0" baseline="0" dirty="0">
                     <a:ln/>
                     <a:solidFill>
                       <a:srgbClr val="4D4D4D"/>
@@ -23061,8 +22363,8 @@
             </p:nvSpPr>
             <p:spPr>
               <a:xfrm>
-                <a:off x="8519981" y="6143143"/>
-                <a:ext cx="482824" cy="246221"/>
+                <a:off x="8519981" y="6177807"/>
+                <a:ext cx="513282" cy="261610"/>
               </a:xfrm>
               <a:prstGeom prst="rect">
                 <a:avLst/>
@@ -23077,7 +22379,7 @@
               <a:p>
                 <a:pPr algn="l"/>
                 <a:r>
-                  <a:rPr lang="en-US" sz="1000" spc="0" baseline="0" dirty="0">
+                  <a:rPr lang="en-US" sz="1100" spc="0" baseline="0" dirty="0">
                     <a:ln/>
                     <a:solidFill>
                       <a:srgbClr val="4D4D4D"/>
@@ -23106,8 +22408,8 @@
             </p:nvSpPr>
             <p:spPr>
               <a:xfrm>
-                <a:off x="9020176" y="6160558"/>
-                <a:ext cx="482824" cy="246221"/>
+                <a:off x="9020176" y="6184332"/>
+                <a:ext cx="513282" cy="261610"/>
               </a:xfrm>
               <a:prstGeom prst="rect">
                 <a:avLst/>
@@ -23122,7 +22424,7 @@
               <a:p>
                 <a:pPr algn="l"/>
                 <a:r>
-                  <a:rPr lang="en-US" sz="1000" spc="0" baseline="0" dirty="0">
+                  <a:rPr lang="en-US" sz="1100" spc="0" baseline="0" dirty="0">
                     <a:ln/>
                     <a:solidFill>
                       <a:srgbClr val="4D4D4D"/>
@@ -23151,8 +22453,8 @@
             </p:nvSpPr>
             <p:spPr>
               <a:xfrm>
-                <a:off x="9525551" y="6160559"/>
-                <a:ext cx="482824" cy="246221"/>
+                <a:off x="9525551" y="6184332"/>
+                <a:ext cx="513282" cy="261610"/>
               </a:xfrm>
               <a:prstGeom prst="rect">
                 <a:avLst/>
@@ -23167,7 +22469,7 @@
               <a:p>
                 <a:pPr algn="l"/>
                 <a:r>
-                  <a:rPr lang="en-US" sz="1000" spc="0" baseline="0" dirty="0">
+                  <a:rPr lang="en-US" sz="1100" spc="0" baseline="0" dirty="0">
                     <a:ln/>
                     <a:solidFill>
                       <a:srgbClr val="4D4D4D"/>
@@ -23196,8 +22498,8 @@
             </p:nvSpPr>
             <p:spPr>
               <a:xfrm>
-                <a:off x="10027965" y="6160557"/>
-                <a:ext cx="482824" cy="246221"/>
+                <a:off x="10027965" y="6184332"/>
+                <a:ext cx="513282" cy="261610"/>
               </a:xfrm>
               <a:prstGeom prst="rect">
                 <a:avLst/>
@@ -23212,7 +22514,7 @@
               <a:p>
                 <a:pPr algn="l"/>
                 <a:r>
-                  <a:rPr lang="en-US" sz="1000" spc="0" baseline="0" dirty="0">
+                  <a:rPr lang="en-US" sz="1100" spc="0" baseline="0" dirty="0">
                     <a:ln/>
                     <a:solidFill>
                       <a:srgbClr val="4D4D4D"/>
@@ -23241,8 +22543,8 @@
             </p:nvSpPr>
             <p:spPr>
               <a:xfrm>
-                <a:off x="10533340" y="6160558"/>
-                <a:ext cx="482824" cy="246221"/>
+                <a:off x="10533340" y="6184332"/>
+                <a:ext cx="513282" cy="261610"/>
               </a:xfrm>
               <a:prstGeom prst="rect">
                 <a:avLst/>
@@ -23257,7 +22559,7 @@
               <a:p>
                 <a:pPr algn="l"/>
                 <a:r>
-                  <a:rPr lang="en-US" sz="1000" spc="0" baseline="0" dirty="0">
+                  <a:rPr lang="en-US" sz="1100" spc="0" baseline="0" dirty="0">
                     <a:ln/>
                     <a:solidFill>
                       <a:srgbClr val="4D4D4D"/>

</xml_diff>